<commit_message>
solo ponemos un alert para copiarl el enlace
</commit_message>
<xml_diff>
--- a/documentos/YourTree.pptx
+++ b/documentos/YourTree.pptx
@@ -2957,7 +2957,7 @@
           <a:bodyPr/>
           <a:lstStyle/>
           <a:p>
-            <a:endParaRPr lang="es-ES">
+            <a:endParaRPr lang="es-ES" noProof="0" dirty="0">
               <a:solidFill>
                 <a:schemeClr val="bg1"/>
               </a:solidFill>
@@ -3001,13 +3001,13 @@
               </a:lnSpc>
             </a:pPr>
             <a:r>
-              <a:rPr lang="en-US" sz="1200" b="1" dirty="0">
+              <a:rPr lang="es-ES" sz="1200" b="1" noProof="0" dirty="0">
                 <a:solidFill>
                   <a:schemeClr val="bg1"/>
                 </a:solidFill>
                 <a:latin typeface="Quattrocento Sans" panose="020B0502050000020003" pitchFamily="34" charset="0"/>
               </a:rPr>
-              <a:t>FUNCIONABILIDAD</a:t>
+              <a:t>USOS Y FUNCIONABILIDAD</a:t>
             </a:r>
           </a:p>
         </p:txBody>
@@ -3041,7 +3041,7 @@
           <a:bodyPr/>
           <a:lstStyle/>
           <a:p>
-            <a:endParaRPr lang="es-ES">
+            <a:endParaRPr lang="es-ES" noProof="0" dirty="0">
               <a:latin typeface="Quattrocento Sans" panose="020B0502050000020003" pitchFamily="34" charset="0"/>
             </a:endParaRPr>
           </a:p>
@@ -3080,7 +3080,7 @@
               </a:lnSpc>
             </a:pPr>
             <a:r>
-              <a:rPr lang="en-US" sz="2800" b="1" dirty="0">
+              <a:rPr lang="es-ES" sz="2800" b="1" noProof="0" dirty="0">
                 <a:solidFill>
                   <a:srgbClr val="1B4332"/>
                 </a:solidFill>
@@ -3088,9 +3088,9 @@
                 <a:ea typeface="QuattrocentoSans" pitchFamily="34" charset="-122"/>
                 <a:cs typeface="QuattrocentoSans" pitchFamily="34" charset="-120"/>
               </a:rPr>
-              <a:t>Metodologías de Gestión y Diseño</a:t>
-            </a:r>
-            <a:endParaRPr lang="en-US" sz="2800" dirty="0">
+              <a:t>Usos de la aplicación</a:t>
+            </a:r>
+            <a:endParaRPr lang="es-ES" sz="2800" noProof="0" dirty="0">
               <a:latin typeface="Quattrocento Sans" panose="020B0502050000020003" pitchFamily="34" charset="0"/>
             </a:endParaRPr>
           </a:p>
@@ -3132,118 +3132,7 @@
           <a:bodyPr/>
           <a:lstStyle/>
           <a:p>
-            <a:endParaRPr lang="es-ES">
-              <a:latin typeface="Quattrocento Sans" panose="020B0502050000020003" pitchFamily="34" charset="0"/>
-            </a:endParaRPr>
-          </a:p>
-        </p:txBody>
-      </p:sp>
-      <p:sp>
-        <p:nvSpPr>
-          <p:cNvPr id="15" name="Shape 13">
-            <a:extLst>
-              <a:ext uri="{FF2B5EF4-FFF2-40B4-BE49-F238E27FC236}">
-                <a16:creationId xmlns:a16="http://schemas.microsoft.com/office/drawing/2014/main" id="{89E7D2CC-C1C2-6EA5-6E58-C1649B970F44}"/>
-              </a:ext>
-            </a:extLst>
-          </p:cNvPr>
-          <p:cNvSpPr/>
-          <p:nvPr/>
-        </p:nvSpPr>
-        <p:spPr>
-          <a:xfrm>
-            <a:off x="1044575" y="1587500"/>
-            <a:ext cx="400050" cy="457200"/>
-          </a:xfrm>
-          <a:custGeom>
-            <a:avLst/>
-            <a:gdLst/>
-            <a:ahLst/>
-            <a:cxnLst/>
-            <a:rect l="l" t="t" r="r" b="b"/>
-            <a:pathLst>
-              <a:path w="400050" h="457200">
-                <a:moveTo>
-                  <a:pt x="0" y="85725"/>
-                </a:moveTo>
-                <a:cubicBezTo>
-                  <a:pt x="0" y="54203"/>
-                  <a:pt x="25628" y="28575"/>
-                  <a:pt x="57150" y="28575"/>
-                </a:cubicBezTo>
-                <a:lnTo>
-                  <a:pt x="342900" y="28575"/>
-                </a:lnTo>
-                <a:cubicBezTo>
-                  <a:pt x="374422" y="28575"/>
-                  <a:pt x="400050" y="54203"/>
-                  <a:pt x="400050" y="85725"/>
-                </a:cubicBezTo>
-                <a:lnTo>
-                  <a:pt x="400050" y="371475"/>
-                </a:lnTo>
-                <a:cubicBezTo>
-                  <a:pt x="400050" y="402997"/>
-                  <a:pt x="374422" y="428625"/>
-                  <a:pt x="342900" y="428625"/>
-                </a:cubicBezTo>
-                <a:lnTo>
-                  <a:pt x="57150" y="428625"/>
-                </a:lnTo>
-                <a:cubicBezTo>
-                  <a:pt x="25628" y="428625"/>
-                  <a:pt x="0" y="402997"/>
-                  <a:pt x="0" y="371475"/>
-                </a:cubicBezTo>
-                <a:lnTo>
-                  <a:pt x="0" y="85725"/>
-                </a:lnTo>
-                <a:close/>
-                <a:moveTo>
-                  <a:pt x="57150" y="142875"/>
-                </a:moveTo>
-                <a:lnTo>
-                  <a:pt x="57150" y="371475"/>
-                </a:lnTo>
-                <a:lnTo>
-                  <a:pt x="171450" y="371475"/>
-                </a:lnTo>
-                <a:lnTo>
-                  <a:pt x="171450" y="142875"/>
-                </a:lnTo>
-                <a:lnTo>
-                  <a:pt x="57150" y="142875"/>
-                </a:lnTo>
-                <a:close/>
-                <a:moveTo>
-                  <a:pt x="342900" y="142875"/>
-                </a:moveTo>
-                <a:lnTo>
-                  <a:pt x="228600" y="142875"/>
-                </a:lnTo>
-                <a:lnTo>
-                  <a:pt x="228600" y="371475"/>
-                </a:lnTo>
-                <a:lnTo>
-                  <a:pt x="342900" y="371475"/>
-                </a:lnTo>
-                <a:lnTo>
-                  <a:pt x="342900" y="142875"/>
-                </a:lnTo>
-                <a:close/>
-              </a:path>
-            </a:pathLst>
-          </a:custGeom>
-          <a:solidFill>
-            <a:srgbClr val="2A9D8F"/>
-          </a:solidFill>
-          <a:ln/>
-        </p:spPr>
-        <p:txBody>
-          <a:bodyPr/>
-          <a:lstStyle/>
-          <a:p>
-            <a:endParaRPr lang="es-ES">
+            <a:endParaRPr lang="es-ES" noProof="0" dirty="0">
               <a:latin typeface="Quattrocento Sans" panose="020B0502050000020003" pitchFamily="34" charset="0"/>
             </a:endParaRPr>
           </a:p>
@@ -3282,7 +3171,7 @@
               </a:lnSpc>
             </a:pPr>
             <a:r>
-              <a:rPr lang="en-US" sz="2000" b="1" dirty="0">
+              <a:rPr lang="es-ES" sz="2000" b="1" noProof="0" dirty="0">
                 <a:solidFill>
                   <a:srgbClr val="1B4332"/>
                 </a:solidFill>
@@ -3290,9 +3179,9 @@
                 <a:ea typeface="Quattrocento Sans" pitchFamily="34" charset="-122"/>
                 <a:cs typeface="Quattrocento Sans" pitchFamily="34" charset="-120"/>
               </a:rPr>
-              <a:t>Kanban &amp; Jira</a:t>
-            </a:r>
-            <a:endParaRPr lang="en-US" sz="1600" dirty="0">
+              <a:t>Difusión</a:t>
+            </a:r>
+            <a:endParaRPr lang="es-ES" sz="1600" noProof="0" dirty="0">
               <a:latin typeface="Quattrocento Sans" panose="020B0502050000020003" pitchFamily="34" charset="0"/>
             </a:endParaRPr>
           </a:p>
@@ -3331,7 +3220,7 @@
               </a:lnSpc>
             </a:pPr>
             <a:r>
-              <a:rPr lang="en-US" sz="1500" dirty="0">
+              <a:rPr lang="es-ES" sz="1500" noProof="0" dirty="0">
                 <a:solidFill>
                   <a:srgbClr val="212529"/>
                 </a:solidFill>
@@ -3339,9 +3228,27 @@
                 <a:ea typeface="QuattrocentoSans" pitchFamily="34" charset="-122"/>
                 <a:cs typeface="QuattrocentoSans" pitchFamily="34" charset="-120"/>
               </a:rPr>
-              <a:t>Control del flujo mediante estados:</a:t>
-            </a:r>
-            <a:endParaRPr lang="en-US" sz="1800" dirty="0">
+              <a:t>Darse a conocer mediante distintos lugares.</a:t>
+            </a:r>
+          </a:p>
+          <a:p>
+            <a:pPr>
+              <a:lnSpc>
+                <a:spcPct val="145000"/>
+              </a:lnSpc>
+            </a:pPr>
+            <a:r>
+              <a:rPr lang="es-ES" sz="1500" noProof="0" dirty="0">
+                <a:solidFill>
+                  <a:srgbClr val="212529"/>
+                </a:solidFill>
+                <a:latin typeface="Quattrocento Sans" panose="020B0502050000020003" pitchFamily="34" charset="0"/>
+                <a:ea typeface="QuattrocentoSans" pitchFamily="34" charset="-122"/>
+                <a:cs typeface="QuattrocentoSans" pitchFamily="34" charset="-120"/>
+              </a:rPr>
+              <a:t>Permite:</a:t>
+            </a:r>
+            <a:endParaRPr lang="es-ES" sz="1800" noProof="0" dirty="0">
               <a:latin typeface="Quattrocento Sans" panose="020B0502050000020003" pitchFamily="34" charset="0"/>
             </a:endParaRPr>
           </a:p>
@@ -3357,30 +3264,15 @@
               <a:buChar char="•"/>
             </a:pPr>
             <a:r>
-              <a:rPr lang="en-US" sz="1500" b="1" dirty="0">
+              <a:rPr lang="es-ES" sz="1500" noProof="0" dirty="0">
                 <a:solidFill>
                   <a:srgbClr val="212529"/>
                 </a:solidFill>
                 <a:latin typeface="Quattrocento Sans" panose="020B0502050000020003" pitchFamily="34" charset="0"/>
                 <a:ea typeface="QuattrocentoSans" pitchFamily="34" charset="-122"/>
-                <a:cs typeface="QuattrocentoSans" pitchFamily="34" charset="-120"/>
-              </a:rPr>
-              <a:t>To-Do</a:t>
-            </a:r>
-            <a:r>
-              <a:rPr lang="en-US" sz="1500" dirty="0">
-                <a:solidFill>
-                  <a:srgbClr val="212529"/>
-                </a:solidFill>
-                <a:latin typeface="Quattrocento Sans" panose="020B0502050000020003" pitchFamily="34" charset="0"/>
-                <a:ea typeface="QuattrocentoSans" pitchFamily="34" charset="-122"/>
-                <a:cs typeface="QuattrocentoSans" pitchFamily="34" charset="-120"/>
-              </a:rPr>
-              <a:t>: Por Hacer</a:t>
-            </a:r>
-            <a:endParaRPr lang="en-US" sz="1800" dirty="0">
-              <a:latin typeface="Quattrocento Sans" panose="020B0502050000020003" pitchFamily="34" charset="0"/>
-            </a:endParaRPr>
+              </a:rPr>
+              <a:t>Dar a conocer tu perfil</a:t>
+            </a:r>
           </a:p>
           <a:p>
             <a:pPr marL="285750" indent="-285750">
@@ -3394,30 +3286,15 @@
               <a:buChar char="•"/>
             </a:pPr>
             <a:r>
-              <a:rPr lang="en-US" sz="1500" b="1" dirty="0">
+              <a:rPr lang="es-ES" sz="1500" noProof="0" dirty="0">
                 <a:solidFill>
                   <a:srgbClr val="212529"/>
                 </a:solidFill>
                 <a:latin typeface="Quattrocento Sans" panose="020B0502050000020003" pitchFamily="34" charset="0"/>
                 <a:ea typeface="QuattrocentoSans" pitchFamily="34" charset="-122"/>
-                <a:cs typeface="QuattrocentoSans" pitchFamily="34" charset="-120"/>
-              </a:rPr>
-              <a:t>In Progress</a:t>
-            </a:r>
-            <a:r>
-              <a:rPr lang="en-US" sz="1500" dirty="0">
-                <a:solidFill>
-                  <a:srgbClr val="212529"/>
-                </a:solidFill>
-                <a:latin typeface="Quattrocento Sans" panose="020B0502050000020003" pitchFamily="34" charset="0"/>
-                <a:ea typeface="QuattrocentoSans" pitchFamily="34" charset="-122"/>
-                <a:cs typeface="QuattrocentoSans" pitchFamily="34" charset="-120"/>
-              </a:rPr>
-              <a:t>: En cursor</a:t>
-            </a:r>
-            <a:endParaRPr lang="en-US" sz="1800" dirty="0">
-              <a:latin typeface="Quattrocento Sans" panose="020B0502050000020003" pitchFamily="34" charset="0"/>
-            </a:endParaRPr>
+              </a:rPr>
+              <a:t>Estar presente en distintas redes sociales.</a:t>
+            </a:r>
           </a:p>
           <a:p>
             <a:pPr marL="285750" indent="-285750">
@@ -3431,100 +3308,16 @@
               <a:buChar char="•"/>
             </a:pPr>
             <a:r>
-              <a:rPr lang="en-US" sz="1500" b="1" dirty="0">
+              <a:rPr lang="es-ES" sz="1500" noProof="0" dirty="0">
                 <a:solidFill>
                   <a:srgbClr val="212529"/>
                 </a:solidFill>
                 <a:latin typeface="Quattrocento Sans" panose="020B0502050000020003" pitchFamily="34" charset="0"/>
                 <a:ea typeface="QuattrocentoSans" pitchFamily="34" charset="-122"/>
-                <a:cs typeface="QuattrocentoSans" pitchFamily="34" charset="-120"/>
-              </a:rPr>
-              <a:t>Review</a:t>
-            </a:r>
-            <a:r>
-              <a:rPr lang="en-US" sz="1500" dirty="0">
-                <a:solidFill>
-                  <a:srgbClr val="212529"/>
-                </a:solidFill>
-                <a:latin typeface="Quattrocento Sans" panose="020B0502050000020003" pitchFamily="34" charset="0"/>
-                <a:ea typeface="QuattrocentoSans" pitchFamily="34" charset="-122"/>
-                <a:cs typeface="QuattrocentoSans" pitchFamily="34" charset="-120"/>
-              </a:rPr>
-              <a:t>: En revisión</a:t>
-            </a:r>
-            <a:endParaRPr lang="en-US" sz="1800" dirty="0">
-              <a:latin typeface="Quattrocento Sans" panose="020B0502050000020003" pitchFamily="34" charset="0"/>
-            </a:endParaRPr>
-          </a:p>
-          <a:p>
-            <a:pPr marL="285750" indent="-285750">
-              <a:lnSpc>
-                <a:spcPct val="145000"/>
-              </a:lnSpc>
-              <a:spcBef>
-                <a:spcPts val="10"/>
-              </a:spcBef>
-              <a:buSzPct val="100000"/>
-              <a:buChar char="•"/>
-            </a:pPr>
-            <a:r>
-              <a:rPr lang="en-US" sz="1500" b="1" dirty="0">
-                <a:solidFill>
-                  <a:srgbClr val="212529"/>
-                </a:solidFill>
-                <a:latin typeface="Quattrocento Sans" panose="020B0502050000020003" pitchFamily="34" charset="0"/>
-                <a:ea typeface="QuattrocentoSans" pitchFamily="34" charset="-122"/>
-                <a:cs typeface="QuattrocentoSans" pitchFamily="34" charset="-120"/>
-              </a:rPr>
-              <a:t>Done</a:t>
-            </a:r>
-            <a:r>
-              <a:rPr lang="en-US" sz="1500" dirty="0">
-                <a:solidFill>
-                  <a:srgbClr val="212529"/>
-                </a:solidFill>
-                <a:latin typeface="Quattrocento Sans" panose="020B0502050000020003" pitchFamily="34" charset="0"/>
-                <a:ea typeface="QuattrocentoSans" pitchFamily="34" charset="-122"/>
-                <a:cs typeface="QuattrocentoSans" pitchFamily="34" charset="-120"/>
-              </a:rPr>
-              <a:t>: </a:t>
-            </a:r>
-            <a:r>
-              <a:rPr lang="en-US" sz="1500" dirty="0" err="1">
-                <a:solidFill>
-                  <a:srgbClr val="212529"/>
-                </a:solidFill>
-                <a:latin typeface="Quattrocento Sans" panose="020B0502050000020003" pitchFamily="34" charset="0"/>
-                <a:ea typeface="QuattrocentoSans" pitchFamily="34" charset="-122"/>
-                <a:cs typeface="QuattrocentoSans" pitchFamily="34" charset="-120"/>
-              </a:rPr>
-              <a:t>Finalizado</a:t>
-            </a:r>
-            <a:endParaRPr lang="en-US" sz="1800" dirty="0">
-              <a:latin typeface="Quattrocento Sans" panose="020B0502050000020003" pitchFamily="34" charset="0"/>
-            </a:endParaRPr>
-          </a:p>
-          <a:p>
-            <a:pPr>
-              <a:lnSpc>
-                <a:spcPct val="145000"/>
-              </a:lnSpc>
-              <a:spcBef>
-                <a:spcPts val="400"/>
-              </a:spcBef>
-            </a:pPr>
-            <a:r>
-              <a:rPr lang="en-US" sz="1500" dirty="0">
-                <a:solidFill>
-                  <a:srgbClr val="212529"/>
-                </a:solidFill>
-                <a:latin typeface="Quattrocento Sans" panose="020B0502050000020003" pitchFamily="34" charset="0"/>
-                <a:ea typeface="QuattrocentoSans" pitchFamily="34" charset="-122"/>
-                <a:cs typeface="QuattrocentoSans" pitchFamily="34" charset="-120"/>
-              </a:rPr>
-              <a:t>Evita cuellos de botella.</a:t>
-            </a:r>
-            <a:endParaRPr lang="en-US" sz="1800" dirty="0">
+              </a:rPr>
+              <a:t>Redirecciona tu trafico a un solo lugar</a:t>
+            </a:r>
+            <a:endParaRPr lang="es-ES" sz="1800" noProof="0" dirty="0">
               <a:latin typeface="Quattrocento Sans" panose="020B0502050000020003" pitchFamily="34" charset="0"/>
             </a:endParaRPr>
           </a:p>
@@ -3566,195 +3359,7 @@
           <a:bodyPr/>
           <a:lstStyle/>
           <a:p>
-            <a:endParaRPr lang="es-ES">
-              <a:latin typeface="Quattrocento Sans" panose="020B0502050000020003" pitchFamily="34" charset="0"/>
-            </a:endParaRPr>
-          </a:p>
-        </p:txBody>
-      </p:sp>
-      <p:sp>
-        <p:nvSpPr>
-          <p:cNvPr id="19" name="Shape 17">
-            <a:extLst>
-              <a:ext uri="{FF2B5EF4-FFF2-40B4-BE49-F238E27FC236}">
-                <a16:creationId xmlns:a16="http://schemas.microsoft.com/office/drawing/2014/main" id="{4EBEF4C6-48B4-3508-7288-58274F512F5A}"/>
-              </a:ext>
-            </a:extLst>
-          </p:cNvPr>
-          <p:cNvSpPr/>
-          <p:nvPr/>
-        </p:nvSpPr>
-        <p:spPr>
-          <a:xfrm>
-            <a:off x="6032500" y="1587500"/>
-            <a:ext cx="457200" cy="457200"/>
-          </a:xfrm>
-          <a:custGeom>
-            <a:avLst/>
-            <a:gdLst/>
-            <a:ahLst/>
-            <a:cxnLst/>
-            <a:rect l="l" t="t" r="r" b="b"/>
-            <a:pathLst>
-              <a:path w="457200" h="457200">
-                <a:moveTo>
-                  <a:pt x="428714" y="171450"/>
-                </a:moveTo>
-                <a:lnTo>
-                  <a:pt x="435769" y="171450"/>
-                </a:lnTo>
-                <a:cubicBezTo>
-                  <a:pt x="447645" y="171450"/>
-                  <a:pt x="457200" y="161895"/>
-                  <a:pt x="457200" y="150019"/>
-                </a:cubicBezTo>
-                <a:lnTo>
-                  <a:pt x="457200" y="21431"/>
-                </a:lnTo>
-                <a:cubicBezTo>
-                  <a:pt x="457200" y="12769"/>
-                  <a:pt x="452021" y="4911"/>
-                  <a:pt x="443984" y="1607"/>
-                </a:cubicBezTo>
-                <a:cubicBezTo>
-                  <a:pt x="435947" y="-1697"/>
-                  <a:pt x="426750" y="179"/>
-                  <a:pt x="420588" y="6251"/>
-                </a:cubicBezTo>
-                <a:lnTo>
-                  <a:pt x="374422" y="52507"/>
-                </a:lnTo>
-                <a:cubicBezTo>
-                  <a:pt x="334863" y="19735"/>
-                  <a:pt x="283964" y="0"/>
-                  <a:pt x="228600" y="0"/>
-                </a:cubicBezTo>
-                <a:cubicBezTo>
-                  <a:pt x="113407" y="0"/>
-                  <a:pt x="18127" y="85189"/>
-                  <a:pt x="2322" y="196007"/>
-                </a:cubicBezTo>
-                <a:cubicBezTo>
-                  <a:pt x="89" y="211634"/>
-                  <a:pt x="10894" y="226100"/>
-                  <a:pt x="26521" y="228332"/>
-                </a:cubicBezTo>
-                <a:cubicBezTo>
-                  <a:pt x="42148" y="230565"/>
-                  <a:pt x="56614" y="219670"/>
-                  <a:pt x="58847" y="204133"/>
-                </a:cubicBezTo>
-                <a:cubicBezTo>
-                  <a:pt x="70723" y="120997"/>
-                  <a:pt x="142250" y="57150"/>
-                  <a:pt x="228600" y="57150"/>
-                </a:cubicBezTo>
-                <a:cubicBezTo>
-                  <a:pt x="268248" y="57150"/>
-                  <a:pt x="304681" y="70545"/>
-                  <a:pt x="333702" y="93137"/>
-                </a:cubicBezTo>
-                <a:lnTo>
-                  <a:pt x="292001" y="134838"/>
-                </a:lnTo>
-                <a:cubicBezTo>
-                  <a:pt x="285839" y="141000"/>
-                  <a:pt x="284053" y="150197"/>
-                  <a:pt x="287357" y="158234"/>
-                </a:cubicBezTo>
-                <a:cubicBezTo>
-                  <a:pt x="290661" y="166271"/>
-                  <a:pt x="298519" y="171450"/>
-                  <a:pt x="307181" y="171450"/>
-                </a:cubicBezTo>
-                <a:lnTo>
-                  <a:pt x="428714" y="171450"/>
-                </a:lnTo>
-                <a:close/>
-                <a:moveTo>
-                  <a:pt x="454968" y="261193"/>
-                </a:moveTo>
-                <a:cubicBezTo>
-                  <a:pt x="457200" y="245566"/>
-                  <a:pt x="446306" y="231100"/>
-                  <a:pt x="430768" y="228868"/>
-                </a:cubicBezTo>
-                <a:cubicBezTo>
-                  <a:pt x="415230" y="226635"/>
-                  <a:pt x="400675" y="237530"/>
-                  <a:pt x="398443" y="253067"/>
-                </a:cubicBezTo>
-                <a:cubicBezTo>
-                  <a:pt x="386566" y="336113"/>
-                  <a:pt x="315039" y="399961"/>
-                  <a:pt x="228689" y="399961"/>
-                </a:cubicBezTo>
-                <a:cubicBezTo>
-                  <a:pt x="189041" y="399961"/>
-                  <a:pt x="152608" y="386566"/>
-                  <a:pt x="123587" y="363974"/>
-                </a:cubicBezTo>
-                <a:lnTo>
-                  <a:pt x="165199" y="322362"/>
-                </a:lnTo>
-                <a:cubicBezTo>
-                  <a:pt x="171361" y="316200"/>
-                  <a:pt x="173147" y="307003"/>
-                  <a:pt x="169843" y="298966"/>
-                </a:cubicBezTo>
-                <a:cubicBezTo>
-                  <a:pt x="166539" y="290929"/>
-                  <a:pt x="158681" y="285750"/>
-                  <a:pt x="150019" y="285750"/>
-                </a:cubicBezTo>
-                <a:lnTo>
-                  <a:pt x="21431" y="285750"/>
-                </a:lnTo>
-                <a:cubicBezTo>
-                  <a:pt x="9555" y="285750"/>
-                  <a:pt x="0" y="295305"/>
-                  <a:pt x="0" y="307181"/>
-                </a:cubicBezTo>
-                <a:lnTo>
-                  <a:pt x="0" y="435769"/>
-                </a:lnTo>
-                <a:cubicBezTo>
-                  <a:pt x="0" y="444431"/>
-                  <a:pt x="5179" y="452289"/>
-                  <a:pt x="13216" y="455593"/>
-                </a:cubicBezTo>
-                <a:cubicBezTo>
-                  <a:pt x="21253" y="458897"/>
-                  <a:pt x="30450" y="457021"/>
-                  <a:pt x="36612" y="450949"/>
-                </a:cubicBezTo>
-                <a:lnTo>
-                  <a:pt x="82867" y="404693"/>
-                </a:lnTo>
-                <a:cubicBezTo>
-                  <a:pt x="122337" y="437465"/>
-                  <a:pt x="173236" y="457200"/>
-                  <a:pt x="228600" y="457200"/>
-                </a:cubicBezTo>
-                <a:cubicBezTo>
-                  <a:pt x="343793" y="457200"/>
-                  <a:pt x="439073" y="372011"/>
-                  <a:pt x="454878" y="261193"/>
-                </a:cubicBezTo>
-                <a:close/>
-              </a:path>
-            </a:pathLst>
-          </a:custGeom>
-          <a:solidFill>
-            <a:srgbClr val="2A9D8F"/>
-          </a:solidFill>
-          <a:ln/>
-        </p:spPr>
-        <p:txBody>
-          <a:bodyPr/>
-          <a:lstStyle/>
-          <a:p>
-            <a:endParaRPr lang="es-ES">
+            <a:endParaRPr lang="es-ES" noProof="0" dirty="0">
               <a:latin typeface="Quattrocento Sans" panose="020B0502050000020003" pitchFamily="34" charset="0"/>
             </a:endParaRPr>
           </a:p>
@@ -3793,7 +3398,7 @@
               </a:lnSpc>
             </a:pPr>
             <a:r>
-              <a:rPr lang="en-US" sz="2000" b="1" dirty="0">
+              <a:rPr lang="es-ES" sz="2000" b="1" noProof="0" dirty="0">
                 <a:solidFill>
                   <a:srgbClr val="1B4332"/>
                 </a:solidFill>
@@ -3801,9 +3406,9 @@
                 <a:ea typeface="Quattrocento Sans" pitchFamily="34" charset="-122"/>
                 <a:cs typeface="Quattrocento Sans" pitchFamily="34" charset="-120"/>
               </a:rPr>
-              <a:t>Scrum-Light</a:t>
-            </a:r>
-            <a:endParaRPr lang="en-US" sz="1600" dirty="0">
+              <a:t>Centralizar</a:t>
+            </a:r>
+            <a:endParaRPr lang="es-ES" sz="1600" noProof="0" dirty="0">
               <a:latin typeface="Quattrocento Sans" panose="020B0502050000020003" pitchFamily="34" charset="0"/>
             </a:endParaRPr>
           </a:p>
@@ -3842,7 +3447,7 @@
               </a:lnSpc>
             </a:pPr>
             <a:r>
-              <a:rPr lang="en-US" sz="1500" dirty="0">
+              <a:rPr lang="es-ES" sz="1500" noProof="0" dirty="0">
                 <a:solidFill>
                   <a:srgbClr val="212529"/>
                 </a:solidFill>
@@ -3850,9 +3455,9 @@
                 <a:ea typeface="QuattrocentoSans" pitchFamily="34" charset="-122"/>
                 <a:cs typeface="QuattrocentoSans" pitchFamily="34" charset="-120"/>
               </a:rPr>
-              <a:t>Ciclos de retroalimentación rápidos para validación de componentes.</a:t>
-            </a:r>
-            <a:endParaRPr lang="en-US" sz="1800" dirty="0">
+              <a:t>Mantener los recursos importantes en un solo lugar.</a:t>
+            </a:r>
+            <a:endParaRPr lang="es-ES" sz="1800" noProof="0" dirty="0">
               <a:latin typeface="Quattrocento Sans" panose="020B0502050000020003" pitchFamily="34" charset="0"/>
             </a:endParaRPr>
           </a:p>
@@ -3866,7 +3471,7 @@
               </a:spcBef>
             </a:pPr>
             <a:r>
-              <a:rPr lang="en-US" sz="1500" dirty="0">
+              <a:rPr lang="es-ES" sz="1500" noProof="0" dirty="0">
                 <a:solidFill>
                   <a:srgbClr val="212529"/>
                 </a:solidFill>
@@ -3874,9 +3479,9 @@
                 <a:ea typeface="QuattrocentoSans" pitchFamily="34" charset="-122"/>
                 <a:cs typeface="QuattrocentoSans" pitchFamily="34" charset="-120"/>
               </a:rPr>
-              <a:t>Permiten:</a:t>
-            </a:r>
-            <a:endParaRPr lang="en-US" sz="1800" dirty="0">
+              <a:t>Permite:</a:t>
+            </a:r>
+            <a:endParaRPr lang="es-ES" sz="1800" noProof="0" dirty="0">
               <a:latin typeface="Quattrocento Sans" panose="020B0502050000020003" pitchFamily="34" charset="0"/>
             </a:endParaRPr>
           </a:p>
@@ -3892,7 +3497,7 @@
               <a:buChar char="•"/>
             </a:pPr>
             <a:r>
-              <a:rPr lang="en-US" sz="1500" dirty="0">
+              <a:rPr lang="es-ES" sz="1500" noProof="0" dirty="0">
                 <a:solidFill>
                   <a:srgbClr val="212529"/>
                 </a:solidFill>
@@ -3900,9 +3505,9 @@
                 <a:ea typeface="QuattrocentoSans" pitchFamily="34" charset="-122"/>
                 <a:cs typeface="QuattrocentoSans" pitchFamily="34" charset="-120"/>
               </a:rPr>
-              <a:t>Detectar problemas temprano</a:t>
-            </a:r>
-            <a:endParaRPr lang="en-US" sz="1800" dirty="0">
+              <a:t>Agrupar los recursos online</a:t>
+            </a:r>
+            <a:endParaRPr lang="es-ES" sz="1800" noProof="0" dirty="0">
               <a:latin typeface="Quattrocento Sans" panose="020B0502050000020003" pitchFamily="34" charset="0"/>
             </a:endParaRPr>
           </a:p>
@@ -3918,7 +3523,7 @@
               <a:buChar char="•"/>
             </a:pPr>
             <a:r>
-              <a:rPr lang="en-US" sz="1500" dirty="0">
+              <a:rPr lang="es-ES" sz="1500" noProof="0" dirty="0">
                 <a:solidFill>
                   <a:srgbClr val="212529"/>
                 </a:solidFill>
@@ -3926,9 +3531,9 @@
                 <a:ea typeface="QuattrocentoSans" pitchFamily="34" charset="-122"/>
                 <a:cs typeface="QuattrocentoSans" pitchFamily="34" charset="-120"/>
               </a:rPr>
-              <a:t>Adaptar requisitos</a:t>
-            </a:r>
-            <a:endParaRPr lang="en-US" sz="1800" dirty="0">
+              <a:t>Definir como se visualizarán</a:t>
+            </a:r>
+            <a:endParaRPr lang="es-ES" sz="1800" noProof="0" dirty="0">
               <a:latin typeface="Quattrocento Sans" panose="020B0502050000020003" pitchFamily="34" charset="0"/>
             </a:endParaRPr>
           </a:p>
@@ -3944,7 +3549,7 @@
               <a:buChar char="•"/>
             </a:pPr>
             <a:r>
-              <a:rPr lang="en-US" sz="1500" dirty="0">
+              <a:rPr lang="es-ES" sz="1500" noProof="0" dirty="0">
                 <a:solidFill>
                   <a:srgbClr val="212529"/>
                 </a:solidFill>
@@ -3952,9 +3557,9 @@
                 <a:ea typeface="QuattrocentoSans" pitchFamily="34" charset="-122"/>
                 <a:cs typeface="QuattrocentoSans" pitchFamily="34" charset="-120"/>
               </a:rPr>
-              <a:t>Entregar valor incremental</a:t>
-            </a:r>
-            <a:endParaRPr lang="en-US" sz="1800" dirty="0">
+              <a:t>Mantener una marca personal</a:t>
+            </a:r>
+            <a:endParaRPr lang="es-ES" sz="1800" noProof="0" dirty="0">
               <a:latin typeface="Quattrocento Sans" panose="020B0502050000020003" pitchFamily="34" charset="0"/>
             </a:endParaRPr>
           </a:p>
@@ -3996,132 +3601,7 @@
           <a:bodyPr/>
           <a:lstStyle/>
           <a:p>
-            <a:endParaRPr lang="es-ES">
-              <a:latin typeface="Quattrocento Sans" panose="020B0502050000020003" pitchFamily="34" charset="0"/>
-            </a:endParaRPr>
-          </a:p>
-        </p:txBody>
-      </p:sp>
-      <p:sp>
-        <p:nvSpPr>
-          <p:cNvPr id="23" name="Shape 21">
-            <a:extLst>
-              <a:ext uri="{FF2B5EF4-FFF2-40B4-BE49-F238E27FC236}">
-                <a16:creationId xmlns:a16="http://schemas.microsoft.com/office/drawing/2014/main" id="{CDAAA348-D9E4-208B-A883-5A458F616C3A}"/>
-              </a:ext>
-            </a:extLst>
-          </p:cNvPr>
-          <p:cNvSpPr/>
-          <p:nvPr/>
-        </p:nvSpPr>
-        <p:spPr>
-          <a:xfrm>
-            <a:off x="11106150" y="1587500"/>
-            <a:ext cx="342900" cy="457200"/>
-          </a:xfrm>
-          <a:custGeom>
-            <a:avLst/>
-            <a:gdLst/>
-            <a:ahLst/>
-            <a:cxnLst/>
-            <a:rect l="l" t="t" r="r" b="b"/>
-            <a:pathLst>
-              <a:path w="342900" h="457200">
-                <a:moveTo>
-                  <a:pt x="14288" y="57150"/>
-                </a:moveTo>
-                <a:cubicBezTo>
-                  <a:pt x="14288" y="25628"/>
-                  <a:pt x="39916" y="0"/>
-                  <a:pt x="71438" y="0"/>
-                </a:cubicBezTo>
-                <a:lnTo>
-                  <a:pt x="271463" y="0"/>
-                </a:lnTo>
-                <a:cubicBezTo>
-                  <a:pt x="302984" y="0"/>
-                  <a:pt x="328613" y="25628"/>
-                  <a:pt x="328613" y="57150"/>
-                </a:cubicBezTo>
-                <a:lnTo>
-                  <a:pt x="328613" y="400050"/>
-                </a:lnTo>
-                <a:cubicBezTo>
-                  <a:pt x="328613" y="431572"/>
-                  <a:pt x="302984" y="457200"/>
-                  <a:pt x="271463" y="457200"/>
-                </a:cubicBezTo>
-                <a:lnTo>
-                  <a:pt x="71438" y="457200"/>
-                </a:lnTo>
-                <a:cubicBezTo>
-                  <a:pt x="39916" y="457200"/>
-                  <a:pt x="14288" y="431572"/>
-                  <a:pt x="14288" y="400050"/>
-                </a:cubicBezTo>
-                <a:lnTo>
-                  <a:pt x="14288" y="57150"/>
-                </a:lnTo>
-                <a:close/>
-                <a:moveTo>
-                  <a:pt x="114300" y="392906"/>
-                </a:moveTo>
-                <a:cubicBezTo>
-                  <a:pt x="114300" y="404783"/>
-                  <a:pt x="123855" y="414338"/>
-                  <a:pt x="135731" y="414338"/>
-                </a:cubicBezTo>
-                <a:lnTo>
-                  <a:pt x="207169" y="414338"/>
-                </a:lnTo>
-                <a:cubicBezTo>
-                  <a:pt x="219045" y="414338"/>
-                  <a:pt x="228600" y="404783"/>
-                  <a:pt x="228600" y="392906"/>
-                </a:cubicBezTo>
-                <a:cubicBezTo>
-                  <a:pt x="228600" y="381030"/>
-                  <a:pt x="219045" y="371475"/>
-                  <a:pt x="207169" y="371475"/>
-                </a:cubicBezTo>
-                <a:lnTo>
-                  <a:pt x="135731" y="371475"/>
-                </a:lnTo>
-                <a:cubicBezTo>
-                  <a:pt x="123855" y="371475"/>
-                  <a:pt x="114300" y="381030"/>
-                  <a:pt x="114300" y="392906"/>
-                </a:cubicBezTo>
-                <a:close/>
-                <a:moveTo>
-                  <a:pt x="271463" y="57150"/>
-                </a:moveTo>
-                <a:lnTo>
-                  <a:pt x="71438" y="57150"/>
-                </a:lnTo>
-                <a:lnTo>
-                  <a:pt x="71438" y="328613"/>
-                </a:lnTo>
-                <a:lnTo>
-                  <a:pt x="271463" y="328613"/>
-                </a:lnTo>
-                <a:lnTo>
-                  <a:pt x="271463" y="57150"/>
-                </a:lnTo>
-                <a:close/>
-              </a:path>
-            </a:pathLst>
-          </a:custGeom>
-          <a:solidFill>
-            <a:srgbClr val="2A9D8F"/>
-          </a:solidFill>
-          <a:ln/>
-        </p:spPr>
-        <p:txBody>
-          <a:bodyPr/>
-          <a:lstStyle/>
-          <a:p>
-            <a:endParaRPr lang="es-ES">
+            <a:endParaRPr lang="es-ES" noProof="0" dirty="0">
               <a:latin typeface="Quattrocento Sans" panose="020B0502050000020003" pitchFamily="34" charset="0"/>
             </a:endParaRPr>
           </a:p>
@@ -4160,7 +3640,7 @@
               </a:lnSpc>
             </a:pPr>
             <a:r>
-              <a:rPr lang="en-US" sz="2000" b="1" dirty="0">
+              <a:rPr lang="es-ES" sz="2000" b="1" noProof="0" dirty="0">
                 <a:solidFill>
                   <a:srgbClr val="1B4332"/>
                 </a:solidFill>
@@ -4168,9 +3648,9 @@
                 <a:ea typeface="Quattrocento Sans" pitchFamily="34" charset="-122"/>
                 <a:cs typeface="Quattrocento Sans" pitchFamily="34" charset="-120"/>
               </a:rPr>
-              <a:t>Mobile-First</a:t>
-            </a:r>
-            <a:endParaRPr lang="en-US" sz="1600" dirty="0">
+              <a:t>Comunidad</a:t>
+            </a:r>
+            <a:endParaRPr lang="es-ES" sz="1600" noProof="0" dirty="0">
               <a:latin typeface="Quattrocento Sans" panose="020B0502050000020003" pitchFamily="34" charset="0"/>
             </a:endParaRPr>
           </a:p>
@@ -4209,7 +3689,7 @@
               </a:lnSpc>
             </a:pPr>
             <a:r>
-              <a:rPr lang="en-US" sz="1500" dirty="0">
+              <a:rPr lang="es-ES" sz="1500" noProof="0" dirty="0">
                 <a:solidFill>
                   <a:srgbClr val="212529"/>
                 </a:solidFill>
@@ -4217,9 +3697,9 @@
                 <a:ea typeface="QuattrocentoSans" pitchFamily="34" charset="-122"/>
                 <a:cs typeface="QuattrocentoSans" pitchFamily="34" charset="-120"/>
               </a:rPr>
-              <a:t>Desarrollo desde la resolución más baja hacia escritorio.</a:t>
-            </a:r>
-            <a:endParaRPr lang="en-US" sz="1800" dirty="0">
+              <a:t>Creación de comunidades para distintos ámbitos.</a:t>
+            </a:r>
+            <a:endParaRPr lang="es-ES" sz="1800" noProof="0" dirty="0">
               <a:latin typeface="Quattrocento Sans" panose="020B0502050000020003" pitchFamily="34" charset="0"/>
             </a:endParaRPr>
           </a:p>
@@ -4233,7 +3713,7 @@
               </a:spcBef>
             </a:pPr>
             <a:r>
-              <a:rPr lang="en-US" sz="1500" dirty="0">
+              <a:rPr lang="es-ES" sz="1500" noProof="0" dirty="0">
                 <a:solidFill>
                   <a:srgbClr val="212529"/>
                 </a:solidFill>
@@ -4241,9 +3721,9 @@
                 <a:ea typeface="QuattrocentoSans" pitchFamily="34" charset="-122"/>
                 <a:cs typeface="QuattrocentoSans" pitchFamily="34" charset="-120"/>
               </a:rPr>
-              <a:t>Garantiza:</a:t>
-            </a:r>
-            <a:endParaRPr lang="en-US" sz="1800" dirty="0">
+              <a:t>Permite:</a:t>
+            </a:r>
+            <a:endParaRPr lang="es-ES" sz="1800" noProof="0" dirty="0">
               <a:latin typeface="Quattrocento Sans" panose="020B0502050000020003" pitchFamily="34" charset="0"/>
             </a:endParaRPr>
           </a:p>
@@ -4259,7 +3739,7 @@
               <a:buChar char="•"/>
             </a:pPr>
             <a:r>
-              <a:rPr lang="en-US" sz="1500" dirty="0">
+              <a:rPr lang="es-ES" sz="1500" noProof="0" dirty="0">
                 <a:solidFill>
                   <a:srgbClr val="212529"/>
                 </a:solidFill>
@@ -4267,9 +3747,9 @@
                 <a:ea typeface="QuattrocentoSans" pitchFamily="34" charset="-122"/>
                 <a:cs typeface="QuattrocentoSans" pitchFamily="34" charset="-120"/>
               </a:rPr>
-              <a:t>Experiencia óptima en móviles</a:t>
-            </a:r>
-            <a:endParaRPr lang="en-US" sz="1800" dirty="0">
+              <a:t>Encontrar usuarios con los mismos gustos</a:t>
+            </a:r>
+            <a:endParaRPr lang="es-ES" sz="1800" noProof="0" dirty="0">
               <a:latin typeface="Quattrocento Sans" panose="020B0502050000020003" pitchFamily="34" charset="0"/>
             </a:endParaRPr>
           </a:p>
@@ -4285,7 +3765,7 @@
               <a:buChar char="•"/>
             </a:pPr>
             <a:r>
-              <a:rPr lang="en-US" sz="1500" dirty="0">
+              <a:rPr lang="es-ES" sz="1500" noProof="0" dirty="0">
                 <a:solidFill>
                   <a:srgbClr val="212529"/>
                 </a:solidFill>
@@ -4293,9 +3773,9 @@
                 <a:ea typeface="QuattrocentoSans" pitchFamily="34" charset="-122"/>
                 <a:cs typeface="QuattrocentoSans" pitchFamily="34" charset="-120"/>
               </a:rPr>
-              <a:t>Progressive enhancement</a:t>
-            </a:r>
-            <a:endParaRPr lang="en-US" sz="1800" dirty="0">
+              <a:t>Crecimiento de marca personal</a:t>
+            </a:r>
+            <a:endParaRPr lang="es-ES" sz="1800" noProof="0" dirty="0">
               <a:latin typeface="Quattrocento Sans" panose="020B0502050000020003" pitchFamily="34" charset="0"/>
             </a:endParaRPr>
           </a:p>
@@ -4311,610 +3791,16 @@
               <a:buChar char="•"/>
             </a:pPr>
             <a:r>
-              <a:rPr lang="en-US" sz="1500" dirty="0">
+              <a:rPr lang="es-ES" sz="1500" noProof="0" dirty="0">
                 <a:solidFill>
                   <a:srgbClr val="212529"/>
                 </a:solidFill>
                 <a:latin typeface="Quattrocento Sans" panose="020B0502050000020003" pitchFamily="34" charset="0"/>
                 <a:ea typeface="QuattrocentoSans" pitchFamily="34" charset="-122"/>
-                <a:cs typeface="QuattrocentoSans" pitchFamily="34" charset="-120"/>
-              </a:rPr>
-              <a:t>Mayor cobertura de usuarios</a:t>
-            </a:r>
-            <a:endParaRPr lang="en-US" sz="1800" dirty="0">
-              <a:latin typeface="Quattrocento Sans" panose="020B0502050000020003" pitchFamily="34" charset="0"/>
-            </a:endParaRPr>
-          </a:p>
-        </p:txBody>
-      </p:sp>
-      <p:sp>
-        <p:nvSpPr>
-          <p:cNvPr id="26" name="Shape 24">
-            <a:extLst>
-              <a:ext uri="{FF2B5EF4-FFF2-40B4-BE49-F238E27FC236}">
-                <a16:creationId xmlns:a16="http://schemas.microsoft.com/office/drawing/2014/main" id="{3BFA88B3-324C-4DD1-1E78-17241449C43C}"/>
-              </a:ext>
-            </a:extLst>
-          </p:cNvPr>
-          <p:cNvSpPr/>
-          <p:nvPr/>
-        </p:nvSpPr>
-        <p:spPr>
-          <a:xfrm>
-            <a:off x="762000" y="5207000"/>
-            <a:ext cx="14732000" cy="25400"/>
-          </a:xfrm>
-          <a:prstGeom prst="rect">
-            <a:avLst/>
-          </a:prstGeom>
-          <a:solidFill>
-            <a:srgbClr val="E9ECEF"/>
-          </a:solidFill>
-          <a:ln/>
-        </p:spPr>
-        <p:txBody>
-          <a:bodyPr/>
-          <a:lstStyle/>
-          <a:p>
-            <a:endParaRPr lang="es-ES">
-              <a:latin typeface="Quattrocento Sans" panose="020B0502050000020003" pitchFamily="34" charset="0"/>
-            </a:endParaRPr>
-          </a:p>
-        </p:txBody>
-      </p:sp>
-      <p:sp>
-        <p:nvSpPr>
-          <p:cNvPr id="27" name="Text 25">
-            <a:extLst>
-              <a:ext uri="{FF2B5EF4-FFF2-40B4-BE49-F238E27FC236}">
-                <a16:creationId xmlns:a16="http://schemas.microsoft.com/office/drawing/2014/main" id="{1B0D8A24-0AB0-F7DD-0098-98906AB26809}"/>
-              </a:ext>
-            </a:extLst>
-          </p:cNvPr>
-          <p:cNvSpPr/>
-          <p:nvPr/>
-        </p:nvSpPr>
-        <p:spPr>
-          <a:xfrm>
-            <a:off x="762000" y="5397500"/>
-            <a:ext cx="5080000" cy="381000"/>
-          </a:xfrm>
-          <a:prstGeom prst="rect">
-            <a:avLst/>
-          </a:prstGeom>
-          <a:noFill/>
-          <a:ln/>
-        </p:spPr>
-        <p:txBody>
-          <a:bodyPr wrap="none" lIns="0" tIns="0" rIns="0" bIns="0" rtlCol="0" anchor="ctr"/>
-          <a:lstStyle/>
-          <a:p>
-            <a:pPr>
-              <a:lnSpc>
-                <a:spcPct val="140000"/>
-              </a:lnSpc>
-            </a:pPr>
-            <a:r>
-              <a:rPr lang="en-US" sz="2000" b="1" dirty="0">
-                <a:solidFill>
-                  <a:srgbClr val="6C757D"/>
-                </a:solidFill>
-                <a:latin typeface="Quattrocento Sans" panose="020B0502050000020003" pitchFamily="34" charset="0"/>
-                <a:ea typeface="QuattrocentoSans" pitchFamily="34" charset="-122"/>
-                <a:cs typeface="QuattrocentoSans" pitchFamily="34" charset="-120"/>
-              </a:rPr>
-              <a:t>Stack Tecnológico</a:t>
-            </a:r>
-            <a:endParaRPr lang="en-US" sz="2000" dirty="0">
-              <a:latin typeface="Quattrocento Sans" panose="020B0502050000020003" pitchFamily="34" charset="0"/>
-            </a:endParaRPr>
-          </a:p>
-        </p:txBody>
-      </p:sp>
-      <p:sp>
-        <p:nvSpPr>
-          <p:cNvPr id="28" name="Shape 26">
-            <a:extLst>
-              <a:ext uri="{FF2B5EF4-FFF2-40B4-BE49-F238E27FC236}">
-                <a16:creationId xmlns:a16="http://schemas.microsoft.com/office/drawing/2014/main" id="{6E2844BE-BD2E-368C-AE12-DA36187F909E}"/>
-              </a:ext>
-            </a:extLst>
-          </p:cNvPr>
-          <p:cNvSpPr/>
-          <p:nvPr/>
-        </p:nvSpPr>
-        <p:spPr>
-          <a:xfrm>
-            <a:off x="762000" y="5969000"/>
-            <a:ext cx="1651000" cy="457200"/>
-          </a:xfrm>
-          <a:prstGeom prst="roundRect">
-            <a:avLst>
-              <a:gd name="adj" fmla="val 16000"/>
-            </a:avLst>
-          </a:prstGeom>
-          <a:solidFill>
-            <a:srgbClr val="1B4332"/>
-          </a:solidFill>
-          <a:ln/>
-        </p:spPr>
-        <p:txBody>
-          <a:bodyPr/>
-          <a:lstStyle/>
-          <a:p>
-            <a:endParaRPr lang="es-ES">
-              <a:latin typeface="Quattrocento Sans" panose="020B0502050000020003" pitchFamily="34" charset="0"/>
-            </a:endParaRPr>
-          </a:p>
-        </p:txBody>
-      </p:sp>
-      <p:sp>
-        <p:nvSpPr>
-          <p:cNvPr id="29" name="Text 27">
-            <a:extLst>
-              <a:ext uri="{FF2B5EF4-FFF2-40B4-BE49-F238E27FC236}">
-                <a16:creationId xmlns:a16="http://schemas.microsoft.com/office/drawing/2014/main" id="{8D1C5ACA-ABE9-FD33-A25F-69AD758E682E}"/>
-              </a:ext>
-            </a:extLst>
-          </p:cNvPr>
-          <p:cNvSpPr/>
-          <p:nvPr/>
-        </p:nvSpPr>
-        <p:spPr>
-          <a:xfrm>
-            <a:off x="762000" y="5969000"/>
-            <a:ext cx="1651000" cy="457200"/>
-          </a:xfrm>
-          <a:prstGeom prst="rect">
-            <a:avLst/>
-          </a:prstGeom>
-          <a:noFill/>
-          <a:ln/>
-        </p:spPr>
-        <p:txBody>
-          <a:bodyPr wrap="none" lIns="0" tIns="0" rIns="0" bIns="0" rtlCol="0" anchor="ctr"/>
-          <a:lstStyle/>
-          <a:p>
-            <a:pPr algn="ctr">
-              <a:lnSpc>
-                <a:spcPct val="100000"/>
-              </a:lnSpc>
-            </a:pPr>
-            <a:r>
-              <a:rPr lang="en-US" sz="1400" b="1" dirty="0">
-                <a:solidFill>
-                  <a:srgbClr val="FFFFFF"/>
-                </a:solidFill>
-                <a:latin typeface="Quattrocento Sans" panose="020B0502050000020003" pitchFamily="34" charset="0"/>
-                <a:ea typeface="QuattrocentoSans" pitchFamily="34" charset="-122"/>
-                <a:cs typeface="QuattrocentoSans" pitchFamily="34" charset="-120"/>
-              </a:rPr>
-              <a:t>React</a:t>
-            </a:r>
-            <a:endParaRPr lang="en-US" sz="1400" dirty="0">
-              <a:latin typeface="Quattrocento Sans" panose="020B0502050000020003" pitchFamily="34" charset="0"/>
-            </a:endParaRPr>
-          </a:p>
-        </p:txBody>
-      </p:sp>
-      <p:sp>
-        <p:nvSpPr>
-          <p:cNvPr id="30" name="Shape 28">
-            <a:extLst>
-              <a:ext uri="{FF2B5EF4-FFF2-40B4-BE49-F238E27FC236}">
-                <a16:creationId xmlns:a16="http://schemas.microsoft.com/office/drawing/2014/main" id="{DC71FDBF-DBC6-B579-3EBA-DB8BCC66FFE2}"/>
-              </a:ext>
-            </a:extLst>
-          </p:cNvPr>
-          <p:cNvSpPr/>
-          <p:nvPr/>
-        </p:nvSpPr>
-        <p:spPr>
-          <a:xfrm>
-            <a:off x="2603500" y="5969000"/>
-            <a:ext cx="2286000" cy="457200"/>
-          </a:xfrm>
-          <a:prstGeom prst="roundRect">
-            <a:avLst>
-              <a:gd name="adj" fmla="val 16000"/>
-            </a:avLst>
-          </a:prstGeom>
-          <a:solidFill>
-            <a:srgbClr val="1B4332"/>
-          </a:solidFill>
-          <a:ln/>
-        </p:spPr>
-        <p:txBody>
-          <a:bodyPr/>
-          <a:lstStyle/>
-          <a:p>
-            <a:endParaRPr lang="es-ES">
-              <a:latin typeface="Quattrocento Sans" panose="020B0502050000020003" pitchFamily="34" charset="0"/>
-            </a:endParaRPr>
-          </a:p>
-        </p:txBody>
-      </p:sp>
-      <p:sp>
-        <p:nvSpPr>
-          <p:cNvPr id="31" name="Text 29">
-            <a:extLst>
-              <a:ext uri="{FF2B5EF4-FFF2-40B4-BE49-F238E27FC236}">
-                <a16:creationId xmlns:a16="http://schemas.microsoft.com/office/drawing/2014/main" id="{5CA5CA65-F90F-2741-9D9D-BAF36B228FE8}"/>
-              </a:ext>
-            </a:extLst>
-          </p:cNvPr>
-          <p:cNvSpPr/>
-          <p:nvPr/>
-        </p:nvSpPr>
-        <p:spPr>
-          <a:xfrm>
-            <a:off x="2603500" y="5969000"/>
-            <a:ext cx="2286000" cy="457200"/>
-          </a:xfrm>
-          <a:prstGeom prst="rect">
-            <a:avLst/>
-          </a:prstGeom>
-          <a:noFill/>
-          <a:ln/>
-        </p:spPr>
-        <p:txBody>
-          <a:bodyPr wrap="none" lIns="0" tIns="0" rIns="0" bIns="0" rtlCol="0" anchor="ctr"/>
-          <a:lstStyle/>
-          <a:p>
-            <a:pPr algn="ctr">
-              <a:lnSpc>
-                <a:spcPct val="100000"/>
-              </a:lnSpc>
-            </a:pPr>
-            <a:r>
-              <a:rPr lang="en-US" sz="1400" b="1" dirty="0">
-                <a:solidFill>
-                  <a:srgbClr val="FFFFFF"/>
-                </a:solidFill>
-                <a:latin typeface="Quattrocento Sans" panose="020B0502050000020003" pitchFamily="34" charset="0"/>
-                <a:ea typeface="QuattrocentoSans" pitchFamily="34" charset="-122"/>
-                <a:cs typeface="QuattrocentoSans" pitchFamily="34" charset="-120"/>
-              </a:rPr>
-              <a:t>Node.js</a:t>
-            </a:r>
-            <a:endParaRPr lang="en-US" sz="1400" dirty="0">
-              <a:latin typeface="Quattrocento Sans" panose="020B0502050000020003" pitchFamily="34" charset="0"/>
-            </a:endParaRPr>
-          </a:p>
-        </p:txBody>
-      </p:sp>
-      <p:sp>
-        <p:nvSpPr>
-          <p:cNvPr id="32" name="Shape 30">
-            <a:extLst>
-              <a:ext uri="{FF2B5EF4-FFF2-40B4-BE49-F238E27FC236}">
-                <a16:creationId xmlns:a16="http://schemas.microsoft.com/office/drawing/2014/main" id="{09F840B6-C22B-C1DB-3B14-175DA4E98C74}"/>
-              </a:ext>
-            </a:extLst>
-          </p:cNvPr>
-          <p:cNvSpPr/>
-          <p:nvPr/>
-        </p:nvSpPr>
-        <p:spPr>
-          <a:xfrm>
-            <a:off x="5080000" y="5969000"/>
-            <a:ext cx="1778000" cy="457200"/>
-          </a:xfrm>
-          <a:prstGeom prst="roundRect">
-            <a:avLst>
-              <a:gd name="adj" fmla="val 16000"/>
-            </a:avLst>
-          </a:prstGeom>
-          <a:solidFill>
-            <a:srgbClr val="1B4332"/>
-          </a:solidFill>
-          <a:ln/>
-        </p:spPr>
-        <p:txBody>
-          <a:bodyPr/>
-          <a:lstStyle/>
-          <a:p>
-            <a:endParaRPr lang="es-ES">
-              <a:latin typeface="Quattrocento Sans" panose="020B0502050000020003" pitchFamily="34" charset="0"/>
-            </a:endParaRPr>
-          </a:p>
-        </p:txBody>
-      </p:sp>
-      <p:sp>
-        <p:nvSpPr>
-          <p:cNvPr id="33" name="Text 31">
-            <a:extLst>
-              <a:ext uri="{FF2B5EF4-FFF2-40B4-BE49-F238E27FC236}">
-                <a16:creationId xmlns:a16="http://schemas.microsoft.com/office/drawing/2014/main" id="{2DA948F6-5353-2F16-5215-AA1D343678B3}"/>
-              </a:ext>
-            </a:extLst>
-          </p:cNvPr>
-          <p:cNvSpPr/>
-          <p:nvPr/>
-        </p:nvSpPr>
-        <p:spPr>
-          <a:xfrm>
-            <a:off x="5080000" y="5969000"/>
-            <a:ext cx="1778000" cy="457200"/>
-          </a:xfrm>
-          <a:prstGeom prst="rect">
-            <a:avLst/>
-          </a:prstGeom>
-          <a:noFill/>
-          <a:ln/>
-        </p:spPr>
-        <p:txBody>
-          <a:bodyPr wrap="none" lIns="0" tIns="0" rIns="0" bIns="0" rtlCol="0" anchor="ctr"/>
-          <a:lstStyle/>
-          <a:p>
-            <a:pPr algn="ctr">
-              <a:lnSpc>
-                <a:spcPct val="100000"/>
-              </a:lnSpc>
-            </a:pPr>
-            <a:r>
-              <a:rPr lang="en-US" sz="1400" b="1" dirty="0">
-                <a:solidFill>
-                  <a:srgbClr val="FFFFFF"/>
-                </a:solidFill>
-                <a:latin typeface="Quattrocento Sans" panose="020B0502050000020003" pitchFamily="34" charset="0"/>
-                <a:ea typeface="QuattrocentoSans" pitchFamily="34" charset="-122"/>
-                <a:cs typeface="QuattrocentoSans" pitchFamily="34" charset="-120"/>
-              </a:rPr>
-              <a:t>PostgreSQL</a:t>
-            </a:r>
-            <a:endParaRPr lang="en-US" sz="1400" dirty="0">
-              <a:latin typeface="Quattrocento Sans" panose="020B0502050000020003" pitchFamily="34" charset="0"/>
-            </a:endParaRPr>
-          </a:p>
-        </p:txBody>
-      </p:sp>
-      <p:sp>
-        <p:nvSpPr>
-          <p:cNvPr id="34" name="Shape 32">
-            <a:extLst>
-              <a:ext uri="{FF2B5EF4-FFF2-40B4-BE49-F238E27FC236}">
-                <a16:creationId xmlns:a16="http://schemas.microsoft.com/office/drawing/2014/main" id="{F8803D43-FE6B-9399-7A09-7161F025515E}"/>
-              </a:ext>
-            </a:extLst>
-          </p:cNvPr>
-          <p:cNvSpPr/>
-          <p:nvPr/>
-        </p:nvSpPr>
-        <p:spPr>
-          <a:xfrm>
-            <a:off x="7048500" y="5969000"/>
-            <a:ext cx="1651000" cy="457200"/>
-          </a:xfrm>
-          <a:prstGeom prst="roundRect">
-            <a:avLst>
-              <a:gd name="adj" fmla="val 16000"/>
-            </a:avLst>
-          </a:prstGeom>
-          <a:solidFill>
-            <a:srgbClr val="1B4332"/>
-          </a:solidFill>
-          <a:ln/>
-        </p:spPr>
-        <p:txBody>
-          <a:bodyPr/>
-          <a:lstStyle/>
-          <a:p>
-            <a:endParaRPr lang="es-ES">
-              <a:latin typeface="Quattrocento Sans" panose="020B0502050000020003" pitchFamily="34" charset="0"/>
-            </a:endParaRPr>
-          </a:p>
-        </p:txBody>
-      </p:sp>
-      <p:sp>
-        <p:nvSpPr>
-          <p:cNvPr id="35" name="Text 33">
-            <a:extLst>
-              <a:ext uri="{FF2B5EF4-FFF2-40B4-BE49-F238E27FC236}">
-                <a16:creationId xmlns:a16="http://schemas.microsoft.com/office/drawing/2014/main" id="{F94A14F6-752A-E7B6-69D2-1D6CCB29EAA3}"/>
-              </a:ext>
-            </a:extLst>
-          </p:cNvPr>
-          <p:cNvSpPr/>
-          <p:nvPr/>
-        </p:nvSpPr>
-        <p:spPr>
-          <a:xfrm>
-            <a:off x="7048500" y="5969000"/>
-            <a:ext cx="1651000" cy="457200"/>
-          </a:xfrm>
-          <a:prstGeom prst="rect">
-            <a:avLst/>
-          </a:prstGeom>
-          <a:noFill/>
-          <a:ln/>
-        </p:spPr>
-        <p:txBody>
-          <a:bodyPr wrap="none" lIns="0" tIns="0" rIns="0" bIns="0" rtlCol="0" anchor="ctr"/>
-          <a:lstStyle/>
-          <a:p>
-            <a:pPr algn="ctr">
-              <a:lnSpc>
-                <a:spcPct val="100000"/>
-              </a:lnSpc>
-            </a:pPr>
-            <a:r>
-              <a:rPr lang="en-US" sz="1400" b="1" dirty="0">
-                <a:solidFill>
-                  <a:srgbClr val="FFFFFF"/>
-                </a:solidFill>
-                <a:latin typeface="Quattrocento Sans" panose="020B0502050000020003" pitchFamily="34" charset="0"/>
-                <a:ea typeface="QuattrocentoSans" pitchFamily="34" charset="-122"/>
-                <a:cs typeface="QuattrocentoSans" pitchFamily="34" charset="-120"/>
-              </a:rPr>
-              <a:t>Docker</a:t>
-            </a:r>
-            <a:endParaRPr lang="en-US" sz="1400" dirty="0">
-              <a:latin typeface="Quattrocento Sans" panose="020B0502050000020003" pitchFamily="34" charset="0"/>
-            </a:endParaRPr>
-          </a:p>
-        </p:txBody>
-      </p:sp>
-      <p:sp>
-        <p:nvSpPr>
-          <p:cNvPr id="36" name="Text 34">
-            <a:extLst>
-              <a:ext uri="{FF2B5EF4-FFF2-40B4-BE49-F238E27FC236}">
-                <a16:creationId xmlns:a16="http://schemas.microsoft.com/office/drawing/2014/main" id="{D9B6445A-81D8-DA25-F2A8-0A440048D924}"/>
-              </a:ext>
-            </a:extLst>
-          </p:cNvPr>
-          <p:cNvSpPr/>
-          <p:nvPr/>
-        </p:nvSpPr>
-        <p:spPr>
-          <a:xfrm>
-            <a:off x="762000" y="6667500"/>
-            <a:ext cx="14732000" cy="1651000"/>
-          </a:xfrm>
-          <a:prstGeom prst="rect">
-            <a:avLst/>
-          </a:prstGeom>
-          <a:noFill/>
-          <a:ln/>
-        </p:spPr>
-        <p:txBody>
-          <a:bodyPr wrap="square" lIns="0" tIns="0" rIns="0" bIns="0" rtlCol="0" anchor="t"/>
-          <a:lstStyle/>
-          <a:p>
-            <a:pPr>
-              <a:lnSpc>
-                <a:spcPct val="150000"/>
-              </a:lnSpc>
-            </a:pPr>
-            <a:r>
-              <a:rPr lang="en-US" sz="1600" b="1" dirty="0">
-                <a:solidFill>
-                  <a:srgbClr val="212529"/>
-                </a:solidFill>
-                <a:latin typeface="Quattrocento Sans" panose="020B0502050000020003" pitchFamily="34" charset="0"/>
-                <a:ea typeface="QuattrocentoSans" pitchFamily="34" charset="-122"/>
-                <a:cs typeface="QuattrocentoSans" pitchFamily="34" charset="-120"/>
-              </a:rPr>
-              <a:t>Frontend:</a:t>
-            </a:r>
-            <a:r>
-              <a:rPr lang="en-US" sz="1600" dirty="0">
-                <a:solidFill>
-                  <a:srgbClr val="212529"/>
-                </a:solidFill>
-                <a:latin typeface="Quattrocento Sans" panose="020B0502050000020003" pitchFamily="34" charset="0"/>
-                <a:ea typeface="QuattrocentoSans" pitchFamily="34" charset="-122"/>
-                <a:cs typeface="QuattrocentoSans" pitchFamily="34" charset="-120"/>
-              </a:rPr>
-              <a:t> React + Vite — SPA de alto rendimiento con componentes reutilizables.</a:t>
-            </a:r>
-            <a:endParaRPr lang="en-US" sz="1800" dirty="0">
-              <a:latin typeface="Quattrocento Sans" panose="020B0502050000020003" pitchFamily="34" charset="0"/>
-            </a:endParaRPr>
-          </a:p>
-          <a:p>
-            <a:pPr>
-              <a:lnSpc>
-                <a:spcPct val="150000"/>
-              </a:lnSpc>
-              <a:spcBef>
-                <a:spcPts val="400"/>
-              </a:spcBef>
-            </a:pPr>
-            <a:r>
-              <a:rPr lang="en-US" sz="1600" b="1" dirty="0">
-                <a:solidFill>
-                  <a:srgbClr val="212529"/>
-                </a:solidFill>
-                <a:latin typeface="Quattrocento Sans" panose="020B0502050000020003" pitchFamily="34" charset="0"/>
-                <a:ea typeface="QuattrocentoSans" pitchFamily="34" charset="-122"/>
-                <a:cs typeface="QuattrocentoSans" pitchFamily="34" charset="-120"/>
-              </a:rPr>
-              <a:t>Backend:</a:t>
-            </a:r>
-            <a:r>
-              <a:rPr lang="en-US" sz="1600" dirty="0">
-                <a:solidFill>
-                  <a:srgbClr val="212529"/>
-                </a:solidFill>
-                <a:latin typeface="Quattrocento Sans" panose="020B0502050000020003" pitchFamily="34" charset="0"/>
-                <a:ea typeface="QuattrocentoSans" pitchFamily="34" charset="-122"/>
-                <a:cs typeface="QuattrocentoSans" pitchFamily="34" charset="-120"/>
-              </a:rPr>
-              <a:t> Node.js + Express.js — arquitectura ligera y escalable con eventos asíncronos.</a:t>
-            </a:r>
-            <a:endParaRPr lang="en-US" sz="1800" dirty="0">
-              <a:latin typeface="Quattrocento Sans" panose="020B0502050000020003" pitchFamily="34" charset="0"/>
-            </a:endParaRPr>
-          </a:p>
-          <a:p>
-            <a:pPr>
-              <a:lnSpc>
-                <a:spcPct val="150000"/>
-              </a:lnSpc>
-              <a:spcBef>
-                <a:spcPts val="400"/>
-              </a:spcBef>
-            </a:pPr>
-            <a:r>
-              <a:rPr lang="en-US" sz="1600" b="1" dirty="0">
-                <a:solidFill>
-                  <a:srgbClr val="212529"/>
-                </a:solidFill>
-                <a:latin typeface="Quattrocento Sans" panose="020B0502050000020003" pitchFamily="34" charset="0"/>
-                <a:ea typeface="QuattrocentoSans" pitchFamily="34" charset="-122"/>
-                <a:cs typeface="QuattrocentoSans" pitchFamily="34" charset="-120"/>
-              </a:rPr>
-              <a:t>Base de datos:</a:t>
-            </a:r>
-            <a:r>
-              <a:rPr lang="en-US" sz="1600" dirty="0">
-                <a:solidFill>
-                  <a:srgbClr val="212529"/>
-                </a:solidFill>
-                <a:latin typeface="Quattrocento Sans" panose="020B0502050000020003" pitchFamily="34" charset="0"/>
-                <a:ea typeface="QuattrocentoSans" pitchFamily="34" charset="-122"/>
-                <a:cs typeface="QuattrocentoSans" pitchFamily="34" charset="-120"/>
-              </a:rPr>
-              <a:t> PostgreSQL— modelo relacional robusto con migraciones automáticas.</a:t>
-            </a:r>
-            <a:endParaRPr lang="en-US" sz="1800" dirty="0">
-              <a:latin typeface="Quattrocento Sans" panose="020B0502050000020003" pitchFamily="34" charset="0"/>
-            </a:endParaRPr>
-          </a:p>
-          <a:p>
-            <a:pPr>
-              <a:lnSpc>
-                <a:spcPct val="150000"/>
-              </a:lnSpc>
-              <a:spcBef>
-                <a:spcPts val="400"/>
-              </a:spcBef>
-            </a:pPr>
-            <a:r>
-              <a:rPr lang="en-US" sz="1600" b="1" dirty="0">
-                <a:solidFill>
-                  <a:srgbClr val="212529"/>
-                </a:solidFill>
-                <a:latin typeface="Quattrocento Sans" panose="020B0502050000020003" pitchFamily="34" charset="0"/>
-                <a:ea typeface="QuattrocentoSans" pitchFamily="34" charset="-122"/>
-                <a:cs typeface="QuattrocentoSans" pitchFamily="34" charset="-120"/>
-              </a:rPr>
-              <a:t>Despliegue:</a:t>
-            </a:r>
-            <a:r>
-              <a:rPr lang="en-US" sz="1600" dirty="0">
-                <a:solidFill>
-                  <a:srgbClr val="212529"/>
-                </a:solidFill>
-                <a:latin typeface="Quattrocento Sans" panose="020B0502050000020003" pitchFamily="34" charset="0"/>
-                <a:ea typeface="QuattrocentoSans" pitchFamily="34" charset="-122"/>
-                <a:cs typeface="QuattrocentoSans" pitchFamily="34" charset="-120"/>
-              </a:rPr>
-              <a:t> Docker + Nginx — contenedores para entornos idénticos y proxy inverso.</a:t>
-            </a:r>
-            <a:endParaRPr lang="en-US" sz="1800" dirty="0">
+              </a:rPr>
+              <a:t>Generar un ambiente sano</a:t>
+            </a:r>
+            <a:endParaRPr lang="es-ES" sz="1800" noProof="0" dirty="0">
               <a:latin typeface="Quattrocento Sans" panose="020B0502050000020003" pitchFamily="34" charset="0"/>
             </a:endParaRPr>
           </a:p>
@@ -4953,7 +3839,7 @@
               </a:lnSpc>
             </a:pPr>
             <a:r>
-              <a:rPr lang="en-US" sz="1400" dirty="0">
+              <a:rPr lang="es-ES" sz="1400" noProof="0" dirty="0">
                 <a:solidFill>
                   <a:srgbClr val="6C757D"/>
                 </a:solidFill>
@@ -4961,9 +3847,9 @@
                 <a:ea typeface="QuattrocentoSans" pitchFamily="34" charset="-122"/>
                 <a:cs typeface="QuattrocentoSans" pitchFamily="34" charset="-120"/>
               </a:rPr>
-              <a:t>3 / 10</a:t>
-            </a:r>
-            <a:endParaRPr lang="en-US" sz="1400" dirty="0">
+              <a:t>10 / 12</a:t>
+            </a:r>
+            <a:endParaRPr lang="es-ES" sz="1400" noProof="0" dirty="0">
               <a:latin typeface="Quattrocento Sans" panose="020B0502050000020003" pitchFamily="34" charset="0"/>
             </a:endParaRPr>
           </a:p>
@@ -5014,6 +3900,219 @@
               </a14:hiddenFill>
             </a:ext>
           </a:extLst>
+        </p:spPr>
+      </p:pic>
+      <p:pic>
+        <p:nvPicPr>
+          <p:cNvPr id="10" name="Imagen 9">
+            <a:extLst>
+              <a:ext uri="{FF2B5EF4-FFF2-40B4-BE49-F238E27FC236}">
+                <a16:creationId xmlns:a16="http://schemas.microsoft.com/office/drawing/2014/main" id="{6C1FAA25-EF0E-B6C0-AA80-84A531FB0DAF}"/>
+              </a:ext>
+            </a:extLst>
+          </p:cNvPr>
+          <p:cNvPicPr>
+            <a:picLocks noChangeAspect="1"/>
+          </p:cNvPicPr>
+          <p:nvPr/>
+        </p:nvPicPr>
+        <p:blipFill>
+          <a:blip r:embed="rId4"/>
+          <a:stretch>
+            <a:fillRect/>
+          </a:stretch>
+        </p:blipFill>
+        <p:spPr>
+          <a:xfrm>
+            <a:off x="812800" y="6148580"/>
+            <a:ext cx="4648200" cy="2043841"/>
+          </a:xfrm>
+          <a:prstGeom prst="roundRect">
+            <a:avLst>
+              <a:gd name="adj" fmla="val 8594"/>
+            </a:avLst>
+          </a:prstGeom>
+          <a:solidFill>
+            <a:srgbClr val="FFFFFF">
+              <a:shade val="85000"/>
+            </a:srgbClr>
+          </a:solidFill>
+          <a:ln>
+            <a:noFill/>
+          </a:ln>
+          <a:effectLst/>
+        </p:spPr>
+      </p:pic>
+      <p:pic>
+        <p:nvPicPr>
+          <p:cNvPr id="38" name="Imagen 37">
+            <a:extLst>
+              <a:ext uri="{FF2B5EF4-FFF2-40B4-BE49-F238E27FC236}">
+                <a16:creationId xmlns:a16="http://schemas.microsoft.com/office/drawing/2014/main" id="{A78F80C8-85C5-0846-04F0-F4446E732FA9}"/>
+              </a:ext>
+            </a:extLst>
+          </p:cNvPr>
+          <p:cNvPicPr>
+            <a:picLocks noChangeAspect="1"/>
+          </p:cNvPicPr>
+          <p:nvPr/>
+        </p:nvPicPr>
+        <p:blipFill>
+          <a:blip r:embed="rId5"/>
+          <a:stretch>
+            <a:fillRect/>
+          </a:stretch>
+        </p:blipFill>
+        <p:spPr>
+          <a:xfrm>
+            <a:off x="5829300" y="5257800"/>
+            <a:ext cx="4648200" cy="3825401"/>
+          </a:xfrm>
+          <a:prstGeom prst="roundRect">
+            <a:avLst>
+              <a:gd name="adj" fmla="val 8594"/>
+            </a:avLst>
+          </a:prstGeom>
+          <a:solidFill>
+            <a:srgbClr val="FFFFFF">
+              <a:shade val="85000"/>
+            </a:srgbClr>
+          </a:solidFill>
+          <a:ln>
+            <a:noFill/>
+          </a:ln>
+          <a:effectLst/>
+        </p:spPr>
+      </p:pic>
+      <p:pic>
+        <p:nvPicPr>
+          <p:cNvPr id="40" name="Imagen 39">
+            <a:extLst>
+              <a:ext uri="{FF2B5EF4-FFF2-40B4-BE49-F238E27FC236}">
+                <a16:creationId xmlns:a16="http://schemas.microsoft.com/office/drawing/2014/main" id="{116EF135-B1E9-443E-D9D9-ED0BD88588A6}"/>
+              </a:ext>
+            </a:extLst>
+          </p:cNvPr>
+          <p:cNvPicPr>
+            <a:picLocks noChangeAspect="1"/>
+          </p:cNvPicPr>
+          <p:nvPr/>
+        </p:nvPicPr>
+        <p:blipFill>
+          <a:blip r:embed="rId6"/>
+          <a:stretch>
+            <a:fillRect/>
+          </a:stretch>
+        </p:blipFill>
+        <p:spPr>
+          <a:xfrm>
+            <a:off x="10845800" y="5630359"/>
+            <a:ext cx="4648200" cy="3080282"/>
+          </a:xfrm>
+          <a:prstGeom prst="roundRect">
+            <a:avLst>
+              <a:gd name="adj" fmla="val 8594"/>
+            </a:avLst>
+          </a:prstGeom>
+          <a:solidFill>
+            <a:srgbClr val="FFFFFF">
+              <a:shade val="85000"/>
+            </a:srgbClr>
+          </a:solidFill>
+          <a:ln>
+            <a:noFill/>
+          </a:ln>
+          <a:effectLst/>
+        </p:spPr>
+      </p:pic>
+      <p:pic>
+        <p:nvPicPr>
+          <p:cNvPr id="44" name="Imagen 43">
+            <a:extLst>
+              <a:ext uri="{FF2B5EF4-FFF2-40B4-BE49-F238E27FC236}">
+                <a16:creationId xmlns:a16="http://schemas.microsoft.com/office/drawing/2014/main" id="{090BD52D-FDEA-642E-7271-E8FF795E278C}"/>
+              </a:ext>
+            </a:extLst>
+          </p:cNvPr>
+          <p:cNvPicPr>
+            <a:picLocks noChangeAspect="1"/>
+          </p:cNvPicPr>
+          <p:nvPr/>
+        </p:nvPicPr>
+        <p:blipFill>
+          <a:blip r:embed="rId7"/>
+          <a:stretch>
+            <a:fillRect/>
+          </a:stretch>
+        </p:blipFill>
+        <p:spPr>
+          <a:xfrm>
+            <a:off x="5829300" y="1387418"/>
+            <a:ext cx="962082" cy="962082"/>
+          </a:xfrm>
+          <a:prstGeom prst="rect">
+            <a:avLst/>
+          </a:prstGeom>
+        </p:spPr>
+      </p:pic>
+      <p:pic>
+        <p:nvPicPr>
+          <p:cNvPr id="46" name="Imagen 45">
+            <a:extLst>
+              <a:ext uri="{FF2B5EF4-FFF2-40B4-BE49-F238E27FC236}">
+                <a16:creationId xmlns:a16="http://schemas.microsoft.com/office/drawing/2014/main" id="{6F56A227-CF1D-C86F-3ACA-EBA25ECF569B}"/>
+              </a:ext>
+            </a:extLst>
+          </p:cNvPr>
+          <p:cNvPicPr>
+            <a:picLocks noChangeAspect="1"/>
+          </p:cNvPicPr>
+          <p:nvPr/>
+        </p:nvPicPr>
+        <p:blipFill>
+          <a:blip r:embed="rId8"/>
+          <a:stretch>
+            <a:fillRect/>
+          </a:stretch>
+        </p:blipFill>
+        <p:spPr>
+          <a:xfrm>
+            <a:off x="11049000" y="1566612"/>
+            <a:ext cx="648926" cy="648926"/>
+          </a:xfrm>
+          <a:prstGeom prst="rect">
+            <a:avLst/>
+          </a:prstGeom>
+        </p:spPr>
+      </p:pic>
+      <p:pic>
+        <p:nvPicPr>
+          <p:cNvPr id="48" name="Imagen 47">
+            <a:extLst>
+              <a:ext uri="{FF2B5EF4-FFF2-40B4-BE49-F238E27FC236}">
+                <a16:creationId xmlns:a16="http://schemas.microsoft.com/office/drawing/2014/main" id="{FE8652F1-BF56-5748-B13F-9EFD229516C6}"/>
+              </a:ext>
+            </a:extLst>
+          </p:cNvPr>
+          <p:cNvPicPr>
+            <a:picLocks noChangeAspect="1"/>
+          </p:cNvPicPr>
+          <p:nvPr/>
+        </p:nvPicPr>
+        <p:blipFill>
+          <a:blip r:embed="rId9"/>
+          <a:stretch>
+            <a:fillRect/>
+          </a:stretch>
+        </p:blipFill>
+        <p:spPr>
+          <a:xfrm>
+            <a:off x="1016000" y="1612900"/>
+            <a:ext cx="482600" cy="482600"/>
+          </a:xfrm>
+          <a:prstGeom prst="rect">
+            <a:avLst/>
+          </a:prstGeom>
         </p:spPr>
       </p:pic>
     </p:spTree>
@@ -5094,7 +4193,7 @@
           <a:bodyPr/>
           <a:lstStyle/>
           <a:p>
-            <a:endParaRPr lang="es-ES">
+            <a:endParaRPr lang="es-ES" noProof="0" dirty="0">
               <a:solidFill>
                 <a:schemeClr val="bg1"/>
               </a:solidFill>
@@ -5138,13 +4237,13 @@
               </a:lnSpc>
             </a:pPr>
             <a:r>
-              <a:rPr lang="en-US" sz="1200" b="1" dirty="0">
+              <a:rPr lang="es-ES" sz="1200" b="1" noProof="0" dirty="0">
                 <a:solidFill>
                   <a:schemeClr val="bg1"/>
                 </a:solidFill>
                 <a:latin typeface="Quattrocento Sans" panose="020B0502050000020003" pitchFamily="34" charset="0"/>
               </a:rPr>
-              <a:t>USOS</a:t>
+              <a:t>USOS Y FUNCIONALIDAD</a:t>
             </a:r>
           </a:p>
         </p:txBody>
@@ -5178,7 +4277,7 @@
           <a:bodyPr/>
           <a:lstStyle/>
           <a:p>
-            <a:endParaRPr lang="es-ES">
+            <a:endParaRPr lang="es-ES" noProof="0" dirty="0">
               <a:latin typeface="Quattrocento Sans" panose="020B0502050000020003" pitchFamily="34" charset="0"/>
             </a:endParaRPr>
           </a:p>
@@ -5217,7 +4316,7 @@
               </a:lnSpc>
             </a:pPr>
             <a:r>
-              <a:rPr lang="en-US" sz="2800" b="1" dirty="0">
+              <a:rPr lang="es-ES" sz="2800" b="1" noProof="0" dirty="0">
                 <a:solidFill>
                   <a:srgbClr val="1B4332"/>
                 </a:solidFill>
@@ -5225,9 +4324,9 @@
                 <a:ea typeface="QuattrocentoSans" pitchFamily="34" charset="-122"/>
                 <a:cs typeface="QuattrocentoSans" pitchFamily="34" charset="-120"/>
               </a:rPr>
-              <a:t>Metodologías de Gestión y Diseño</a:t>
-            </a:r>
-            <a:endParaRPr lang="en-US" sz="2800" dirty="0">
+              <a:t>Funcionalidad de la aplicación </a:t>
+            </a:r>
+            <a:endParaRPr lang="es-ES" sz="2800" noProof="0" dirty="0">
               <a:latin typeface="Quattrocento Sans" panose="020B0502050000020003" pitchFamily="34" charset="0"/>
             </a:endParaRPr>
           </a:p>
@@ -5247,8 +4346,8 @@
         </p:nvSpPr>
         <p:spPr>
           <a:xfrm>
-            <a:off x="762000" y="1397000"/>
-            <a:ext cx="4699000" cy="3556000"/>
+            <a:off x="5778500" y="1402692"/>
+            <a:ext cx="4699000" cy="3862989"/>
           </a:xfrm>
           <a:prstGeom prst="roundRect">
             <a:avLst>
@@ -5269,118 +4368,7 @@
           <a:bodyPr/>
           <a:lstStyle/>
           <a:p>
-            <a:endParaRPr lang="es-ES">
-              <a:latin typeface="Quattrocento Sans" panose="020B0502050000020003" pitchFamily="34" charset="0"/>
-            </a:endParaRPr>
-          </a:p>
-        </p:txBody>
-      </p:sp>
-      <p:sp>
-        <p:nvSpPr>
-          <p:cNvPr id="15" name="Shape 13">
-            <a:extLst>
-              <a:ext uri="{FF2B5EF4-FFF2-40B4-BE49-F238E27FC236}">
-                <a16:creationId xmlns:a16="http://schemas.microsoft.com/office/drawing/2014/main" id="{22444C52-908A-9156-A8A3-414F6A5E9AA3}"/>
-              </a:ext>
-            </a:extLst>
-          </p:cNvPr>
-          <p:cNvSpPr/>
-          <p:nvPr/>
-        </p:nvSpPr>
-        <p:spPr>
-          <a:xfrm>
-            <a:off x="1044575" y="1587500"/>
-            <a:ext cx="400050" cy="457200"/>
-          </a:xfrm>
-          <a:custGeom>
-            <a:avLst/>
-            <a:gdLst/>
-            <a:ahLst/>
-            <a:cxnLst/>
-            <a:rect l="l" t="t" r="r" b="b"/>
-            <a:pathLst>
-              <a:path w="400050" h="457200">
-                <a:moveTo>
-                  <a:pt x="0" y="85725"/>
-                </a:moveTo>
-                <a:cubicBezTo>
-                  <a:pt x="0" y="54203"/>
-                  <a:pt x="25628" y="28575"/>
-                  <a:pt x="57150" y="28575"/>
-                </a:cubicBezTo>
-                <a:lnTo>
-                  <a:pt x="342900" y="28575"/>
-                </a:lnTo>
-                <a:cubicBezTo>
-                  <a:pt x="374422" y="28575"/>
-                  <a:pt x="400050" y="54203"/>
-                  <a:pt x="400050" y="85725"/>
-                </a:cubicBezTo>
-                <a:lnTo>
-                  <a:pt x="400050" y="371475"/>
-                </a:lnTo>
-                <a:cubicBezTo>
-                  <a:pt x="400050" y="402997"/>
-                  <a:pt x="374422" y="428625"/>
-                  <a:pt x="342900" y="428625"/>
-                </a:cubicBezTo>
-                <a:lnTo>
-                  <a:pt x="57150" y="428625"/>
-                </a:lnTo>
-                <a:cubicBezTo>
-                  <a:pt x="25628" y="428625"/>
-                  <a:pt x="0" y="402997"/>
-                  <a:pt x="0" y="371475"/>
-                </a:cubicBezTo>
-                <a:lnTo>
-                  <a:pt x="0" y="85725"/>
-                </a:lnTo>
-                <a:close/>
-                <a:moveTo>
-                  <a:pt x="57150" y="142875"/>
-                </a:moveTo>
-                <a:lnTo>
-                  <a:pt x="57150" y="371475"/>
-                </a:lnTo>
-                <a:lnTo>
-                  <a:pt x="171450" y="371475"/>
-                </a:lnTo>
-                <a:lnTo>
-                  <a:pt x="171450" y="142875"/>
-                </a:lnTo>
-                <a:lnTo>
-                  <a:pt x="57150" y="142875"/>
-                </a:lnTo>
-                <a:close/>
-                <a:moveTo>
-                  <a:pt x="342900" y="142875"/>
-                </a:moveTo>
-                <a:lnTo>
-                  <a:pt x="228600" y="142875"/>
-                </a:lnTo>
-                <a:lnTo>
-                  <a:pt x="228600" y="371475"/>
-                </a:lnTo>
-                <a:lnTo>
-                  <a:pt x="342900" y="371475"/>
-                </a:lnTo>
-                <a:lnTo>
-                  <a:pt x="342900" y="142875"/>
-                </a:lnTo>
-                <a:close/>
-              </a:path>
-            </a:pathLst>
-          </a:custGeom>
-          <a:solidFill>
-            <a:srgbClr val="2A9D8F"/>
-          </a:solidFill>
-          <a:ln/>
-        </p:spPr>
-        <p:txBody>
-          <a:bodyPr/>
-          <a:lstStyle/>
-          <a:p>
-            <a:endParaRPr lang="es-ES">
+            <a:endParaRPr lang="es-ES" noProof="0" dirty="0">
               <a:latin typeface="Quattrocento Sans" panose="020B0502050000020003" pitchFamily="34" charset="0"/>
             </a:endParaRPr>
           </a:p>
@@ -5400,7 +4388,7 @@
         </p:nvSpPr>
         <p:spPr>
           <a:xfrm>
-            <a:off x="1016000" y="2159000"/>
+            <a:off x="6032500" y="2164693"/>
             <a:ext cx="4191000" cy="381000"/>
           </a:xfrm>
           <a:prstGeom prst="rect">
@@ -5419,7 +4407,7 @@
               </a:lnSpc>
             </a:pPr>
             <a:r>
-              <a:rPr lang="en-US" sz="2000" b="1" dirty="0">
+              <a:rPr lang="es-ES" sz="2000" b="1" noProof="0" dirty="0">
                 <a:solidFill>
                   <a:srgbClr val="1B4332"/>
                 </a:solidFill>
@@ -5427,9 +4415,9 @@
                 <a:ea typeface="Quattrocento Sans" pitchFamily="34" charset="-122"/>
                 <a:cs typeface="Quattrocento Sans" pitchFamily="34" charset="-120"/>
               </a:rPr>
-              <a:t>Kanban &amp; Jira</a:t>
-            </a:r>
-            <a:endParaRPr lang="en-US" sz="1600" dirty="0">
+              <a:t>Gestión de enlaces</a:t>
+            </a:r>
+            <a:endParaRPr lang="es-ES" sz="1600" noProof="0" dirty="0">
               <a:latin typeface="Quattrocento Sans" panose="020B0502050000020003" pitchFamily="34" charset="0"/>
             </a:endParaRPr>
           </a:p>
@@ -5449,7 +4437,7 @@
         </p:nvSpPr>
         <p:spPr>
           <a:xfrm>
-            <a:off x="1016000" y="2641600"/>
+            <a:off x="6032500" y="2647293"/>
             <a:ext cx="4191000" cy="2222500"/>
           </a:xfrm>
           <a:prstGeom prst="rect">
@@ -5468,7 +4456,7 @@
               </a:lnSpc>
             </a:pPr>
             <a:r>
-              <a:rPr lang="en-US" sz="1500" dirty="0">
+              <a:rPr lang="es-ES" sz="1500" noProof="0" dirty="0">
                 <a:solidFill>
                   <a:srgbClr val="212529"/>
                 </a:solidFill>
@@ -5476,9 +4464,27 @@
                 <a:ea typeface="QuattrocentoSans" pitchFamily="34" charset="-122"/>
                 <a:cs typeface="QuattrocentoSans" pitchFamily="34" charset="-120"/>
               </a:rPr>
-              <a:t>Control del flujo mediante estados:</a:t>
-            </a:r>
-            <a:endParaRPr lang="en-US" sz="1800" dirty="0">
+              <a:t>Funcionalidad que permite centralizar de forma correcta los enlaces. </a:t>
+            </a:r>
+          </a:p>
+          <a:p>
+            <a:pPr>
+              <a:lnSpc>
+                <a:spcPct val="145000"/>
+              </a:lnSpc>
+            </a:pPr>
+            <a:r>
+              <a:rPr lang="es-ES" sz="1500" noProof="0" dirty="0">
+                <a:solidFill>
+                  <a:srgbClr val="212529"/>
+                </a:solidFill>
+                <a:latin typeface="Quattrocento Sans" panose="020B0502050000020003" pitchFamily="34" charset="0"/>
+                <a:ea typeface="QuattrocentoSans" pitchFamily="34" charset="-122"/>
+                <a:cs typeface="QuattrocentoSans" pitchFamily="34" charset="-120"/>
+              </a:rPr>
+              <a:t>Permiten:</a:t>
+            </a:r>
+            <a:endParaRPr lang="es-ES" sz="1800" noProof="0" dirty="0">
               <a:latin typeface="Quattrocento Sans" panose="020B0502050000020003" pitchFamily="34" charset="0"/>
             </a:endParaRPr>
           </a:p>
@@ -5494,30 +4500,15 @@
               <a:buChar char="•"/>
             </a:pPr>
             <a:r>
-              <a:rPr lang="en-US" sz="1500" b="1" dirty="0">
+              <a:rPr lang="es-ES" sz="1500" dirty="0">
                 <a:solidFill>
                   <a:srgbClr val="212529"/>
                 </a:solidFill>
                 <a:latin typeface="Quattrocento Sans" panose="020B0502050000020003" pitchFamily="34" charset="0"/>
                 <a:ea typeface="QuattrocentoSans" pitchFamily="34" charset="-122"/>
-                <a:cs typeface="QuattrocentoSans" pitchFamily="34" charset="-120"/>
-              </a:rPr>
-              <a:t>To-Do</a:t>
-            </a:r>
-            <a:r>
-              <a:rPr lang="en-US" sz="1500" dirty="0">
-                <a:solidFill>
-                  <a:srgbClr val="212529"/>
-                </a:solidFill>
-                <a:latin typeface="Quattrocento Sans" panose="020B0502050000020003" pitchFamily="34" charset="0"/>
-                <a:ea typeface="QuattrocentoSans" pitchFamily="34" charset="-122"/>
-                <a:cs typeface="QuattrocentoSans" pitchFamily="34" charset="-120"/>
-              </a:rPr>
-              <a:t>: Por Hacer</a:t>
-            </a:r>
-            <a:endParaRPr lang="en-US" sz="1800" dirty="0">
-              <a:latin typeface="Quattrocento Sans" panose="020B0502050000020003" pitchFamily="34" charset="0"/>
-            </a:endParaRPr>
+              </a:rPr>
+              <a:t>Administración de enlaces personalizados</a:t>
+            </a:r>
           </a:p>
           <a:p>
             <a:pPr marL="285750" indent="-285750">
@@ -5531,30 +4522,15 @@
               <a:buChar char="•"/>
             </a:pPr>
             <a:r>
-              <a:rPr lang="en-US" sz="1500" b="1" dirty="0">
+              <a:rPr lang="es-ES" sz="1500" dirty="0">
                 <a:solidFill>
                   <a:srgbClr val="212529"/>
                 </a:solidFill>
                 <a:latin typeface="Quattrocento Sans" panose="020B0502050000020003" pitchFamily="34" charset="0"/>
                 <a:ea typeface="QuattrocentoSans" pitchFamily="34" charset="-122"/>
-                <a:cs typeface="QuattrocentoSans" pitchFamily="34" charset="-120"/>
-              </a:rPr>
-              <a:t>In Progress</a:t>
-            </a:r>
-            <a:r>
-              <a:rPr lang="en-US" sz="1500" dirty="0">
-                <a:solidFill>
-                  <a:srgbClr val="212529"/>
-                </a:solidFill>
-                <a:latin typeface="Quattrocento Sans" panose="020B0502050000020003" pitchFamily="34" charset="0"/>
-                <a:ea typeface="QuattrocentoSans" pitchFamily="34" charset="-122"/>
-                <a:cs typeface="QuattrocentoSans" pitchFamily="34" charset="-120"/>
-              </a:rPr>
-              <a:t>: En cursor</a:t>
-            </a:r>
-            <a:endParaRPr lang="en-US" sz="1800" dirty="0">
-              <a:latin typeface="Quattrocento Sans" panose="020B0502050000020003" pitchFamily="34" charset="0"/>
-            </a:endParaRPr>
+              </a:rPr>
+              <a:t>Control de visibilidad de enlaces </a:t>
+            </a:r>
           </a:p>
           <a:p>
             <a:pPr marL="285750" indent="-285750">
@@ -5568,102 +4544,15 @@
               <a:buChar char="•"/>
             </a:pPr>
             <a:r>
-              <a:rPr lang="en-US" sz="1500" b="1" dirty="0">
+              <a:rPr lang="es-ES" sz="1500" dirty="0">
                 <a:solidFill>
                   <a:srgbClr val="212529"/>
                 </a:solidFill>
                 <a:latin typeface="Quattrocento Sans" panose="020B0502050000020003" pitchFamily="34" charset="0"/>
                 <a:ea typeface="QuattrocentoSans" pitchFamily="34" charset="-122"/>
-                <a:cs typeface="QuattrocentoSans" pitchFamily="34" charset="-120"/>
-              </a:rPr>
-              <a:t>Review</a:t>
-            </a:r>
-            <a:r>
-              <a:rPr lang="en-US" sz="1500" dirty="0">
-                <a:solidFill>
-                  <a:srgbClr val="212529"/>
-                </a:solidFill>
-                <a:latin typeface="Quattrocento Sans" panose="020B0502050000020003" pitchFamily="34" charset="0"/>
-                <a:ea typeface="QuattrocentoSans" pitchFamily="34" charset="-122"/>
-                <a:cs typeface="QuattrocentoSans" pitchFamily="34" charset="-120"/>
-              </a:rPr>
-              <a:t>: En revisión</a:t>
-            </a:r>
-            <a:endParaRPr lang="en-US" sz="1800" dirty="0">
-              <a:latin typeface="Quattrocento Sans" panose="020B0502050000020003" pitchFamily="34" charset="0"/>
-            </a:endParaRPr>
-          </a:p>
-          <a:p>
-            <a:pPr marL="285750" indent="-285750">
-              <a:lnSpc>
-                <a:spcPct val="145000"/>
-              </a:lnSpc>
-              <a:spcBef>
-                <a:spcPts val="10"/>
-              </a:spcBef>
-              <a:buSzPct val="100000"/>
-              <a:buChar char="•"/>
-            </a:pPr>
-            <a:r>
-              <a:rPr lang="en-US" sz="1500" b="1" dirty="0">
-                <a:solidFill>
-                  <a:srgbClr val="212529"/>
-                </a:solidFill>
-                <a:latin typeface="Quattrocento Sans" panose="020B0502050000020003" pitchFamily="34" charset="0"/>
-                <a:ea typeface="QuattrocentoSans" pitchFamily="34" charset="-122"/>
-                <a:cs typeface="QuattrocentoSans" pitchFamily="34" charset="-120"/>
-              </a:rPr>
-              <a:t>Done</a:t>
-            </a:r>
-            <a:r>
-              <a:rPr lang="en-US" sz="1500" dirty="0">
-                <a:solidFill>
-                  <a:srgbClr val="212529"/>
-                </a:solidFill>
-                <a:latin typeface="Quattrocento Sans" panose="020B0502050000020003" pitchFamily="34" charset="0"/>
-                <a:ea typeface="QuattrocentoSans" pitchFamily="34" charset="-122"/>
-                <a:cs typeface="QuattrocentoSans" pitchFamily="34" charset="-120"/>
-              </a:rPr>
-              <a:t>: </a:t>
-            </a:r>
-            <a:r>
-              <a:rPr lang="en-US" sz="1500" dirty="0" err="1">
-                <a:solidFill>
-                  <a:srgbClr val="212529"/>
-                </a:solidFill>
-                <a:latin typeface="Quattrocento Sans" panose="020B0502050000020003" pitchFamily="34" charset="0"/>
-                <a:ea typeface="QuattrocentoSans" pitchFamily="34" charset="-122"/>
-                <a:cs typeface="QuattrocentoSans" pitchFamily="34" charset="-120"/>
-              </a:rPr>
-              <a:t>Finalizado</a:t>
-            </a:r>
-            <a:endParaRPr lang="en-US" sz="1800" dirty="0">
-              <a:latin typeface="Quattrocento Sans" panose="020B0502050000020003" pitchFamily="34" charset="0"/>
-            </a:endParaRPr>
-          </a:p>
-          <a:p>
-            <a:pPr>
-              <a:lnSpc>
-                <a:spcPct val="145000"/>
-              </a:lnSpc>
-              <a:spcBef>
-                <a:spcPts val="400"/>
-              </a:spcBef>
-            </a:pPr>
-            <a:r>
-              <a:rPr lang="en-US" sz="1500" dirty="0">
-                <a:solidFill>
-                  <a:srgbClr val="212529"/>
-                </a:solidFill>
-                <a:latin typeface="Quattrocento Sans" panose="020B0502050000020003" pitchFamily="34" charset="0"/>
-                <a:ea typeface="QuattrocentoSans" pitchFamily="34" charset="-122"/>
-                <a:cs typeface="QuattrocentoSans" pitchFamily="34" charset="-120"/>
-              </a:rPr>
-              <a:t>Evita cuellos de botella.</a:t>
-            </a:r>
-            <a:endParaRPr lang="en-US" sz="1800" dirty="0">
-              <a:latin typeface="Quattrocento Sans" panose="020B0502050000020003" pitchFamily="34" charset="0"/>
-            </a:endParaRPr>
+              </a:rPr>
+              <a:t>Organización mediante interfaz intuitiva</a:t>
+            </a:r>
           </a:p>
         </p:txBody>
       </p:sp>
@@ -5681,8 +4570,8 @@
         </p:nvSpPr>
         <p:spPr>
           <a:xfrm>
-            <a:off x="5778500" y="1397000"/>
-            <a:ext cx="4699000" cy="3556000"/>
+            <a:off x="10794999" y="1402693"/>
+            <a:ext cx="4699000" cy="3862990"/>
           </a:xfrm>
           <a:prstGeom prst="roundRect">
             <a:avLst>
@@ -5703,7 +4592,7 @@
           <a:bodyPr/>
           <a:lstStyle/>
           <a:p>
-            <a:endParaRPr lang="es-ES">
+            <a:endParaRPr lang="es-ES" noProof="0" dirty="0">
               <a:latin typeface="Quattrocento Sans" panose="020B0502050000020003" pitchFamily="34" charset="0"/>
             </a:endParaRPr>
           </a:p>
@@ -5723,7 +4612,7 @@
         </p:nvSpPr>
         <p:spPr>
           <a:xfrm>
-            <a:off x="6032500" y="1587500"/>
+            <a:off x="11048999" y="1593193"/>
             <a:ext cx="457200" cy="457200"/>
           </a:xfrm>
           <a:custGeom>
@@ -5891,7 +4780,7 @@
           <a:bodyPr/>
           <a:lstStyle/>
           <a:p>
-            <a:endParaRPr lang="es-ES">
+            <a:endParaRPr lang="es-ES" noProof="0" dirty="0">
               <a:latin typeface="Quattrocento Sans" panose="020B0502050000020003" pitchFamily="34" charset="0"/>
             </a:endParaRPr>
           </a:p>
@@ -5911,7 +4800,7 @@
         </p:nvSpPr>
         <p:spPr>
           <a:xfrm>
-            <a:off x="6032500" y="2159000"/>
+            <a:off x="11048999" y="2164693"/>
             <a:ext cx="4191000" cy="381000"/>
           </a:xfrm>
           <a:prstGeom prst="rect">
@@ -5930,7 +4819,7 @@
               </a:lnSpc>
             </a:pPr>
             <a:r>
-              <a:rPr lang="en-US" sz="2000" b="1" dirty="0">
+              <a:rPr lang="es-ES" sz="2000" b="1" noProof="0" dirty="0">
                 <a:solidFill>
                   <a:srgbClr val="1B4332"/>
                 </a:solidFill>
@@ -5938,9 +4827,9 @@
                 <a:ea typeface="Quattrocento Sans" pitchFamily="34" charset="-122"/>
                 <a:cs typeface="Quattrocento Sans" pitchFamily="34" charset="-120"/>
               </a:rPr>
-              <a:t>Scrum-Light</a:t>
-            </a:r>
-            <a:endParaRPr lang="en-US" sz="1600" dirty="0">
+              <a:t>Sistema de interacción</a:t>
+            </a:r>
+            <a:endParaRPr lang="es-ES" sz="1600" noProof="0" dirty="0">
               <a:latin typeface="Quattrocento Sans" panose="020B0502050000020003" pitchFamily="34" charset="0"/>
             </a:endParaRPr>
           </a:p>
@@ -5960,7 +4849,7 @@
         </p:nvSpPr>
         <p:spPr>
           <a:xfrm>
-            <a:off x="6032500" y="2641600"/>
+            <a:off x="11048999" y="2647293"/>
             <a:ext cx="4191000" cy="2222500"/>
           </a:xfrm>
           <a:prstGeom prst="rect">
@@ -5979,7 +4868,7 @@
               </a:lnSpc>
             </a:pPr>
             <a:r>
-              <a:rPr lang="en-US" sz="1500" dirty="0">
+              <a:rPr lang="es-ES" sz="1500" noProof="0" dirty="0">
                 <a:solidFill>
                   <a:srgbClr val="212529"/>
                 </a:solidFill>
@@ -5987,9 +4876,9 @@
                 <a:ea typeface="QuattrocentoSans" pitchFamily="34" charset="-122"/>
                 <a:cs typeface="QuattrocentoSans" pitchFamily="34" charset="-120"/>
               </a:rPr>
-              <a:t>Ciclos de retroalimentación rápidos para validación de componentes.</a:t>
-            </a:r>
-            <a:endParaRPr lang="en-US" sz="1800" dirty="0">
+              <a:t>Funcionalidad que permite la interacción de una comunidad.</a:t>
+            </a:r>
+            <a:endParaRPr lang="es-ES" sz="1800" noProof="0" dirty="0">
               <a:latin typeface="Quattrocento Sans" panose="020B0502050000020003" pitchFamily="34" charset="0"/>
             </a:endParaRPr>
           </a:p>
@@ -6003,19 +4892,15 @@
               </a:spcBef>
             </a:pPr>
             <a:r>
-              <a:rPr lang="en-US" sz="1500" dirty="0">
+              <a:rPr lang="es-ES" sz="1500" dirty="0">
                 <a:solidFill>
                   <a:srgbClr val="212529"/>
                 </a:solidFill>
                 <a:latin typeface="Quattrocento Sans" panose="020B0502050000020003" pitchFamily="34" charset="0"/>
                 <a:ea typeface="QuattrocentoSans" pitchFamily="34" charset="-122"/>
-                <a:cs typeface="QuattrocentoSans" pitchFamily="34" charset="-120"/>
               </a:rPr>
               <a:t>Permiten:</a:t>
             </a:r>
-            <a:endParaRPr lang="en-US" sz="1800" dirty="0">
-              <a:latin typeface="Quattrocento Sans" panose="020B0502050000020003" pitchFamily="34" charset="0"/>
-            </a:endParaRPr>
           </a:p>
           <a:p>
             <a:pPr marL="285750" indent="-285750">
@@ -6029,19 +4914,15 @@
               <a:buChar char="•"/>
             </a:pPr>
             <a:r>
-              <a:rPr lang="en-US" sz="1500" dirty="0">
+              <a:rPr lang="es-ES" sz="1500" dirty="0">
                 <a:solidFill>
                   <a:srgbClr val="212529"/>
                 </a:solidFill>
                 <a:latin typeface="Quattrocento Sans" panose="020B0502050000020003" pitchFamily="34" charset="0"/>
                 <a:ea typeface="QuattrocentoSans" pitchFamily="34" charset="-122"/>
-                <a:cs typeface="QuattrocentoSans" pitchFamily="34" charset="-120"/>
-              </a:rPr>
-              <a:t>Detectar problemas temprano</a:t>
-            </a:r>
-            <a:endParaRPr lang="en-US" sz="1800" dirty="0">
-              <a:latin typeface="Quattrocento Sans" panose="020B0502050000020003" pitchFamily="34" charset="0"/>
-            </a:endParaRPr>
+              </a:rPr>
+              <a:t>Creación de hilos de discusión por temáticas</a:t>
+            </a:r>
           </a:p>
           <a:p>
             <a:pPr marL="285750" indent="-285750">
@@ -6055,19 +4936,15 @@
               <a:buChar char="•"/>
             </a:pPr>
             <a:r>
-              <a:rPr lang="en-US" sz="1500" dirty="0">
+              <a:rPr lang="es-ES" sz="1500" dirty="0">
                 <a:solidFill>
                   <a:srgbClr val="212529"/>
                 </a:solidFill>
                 <a:latin typeface="Quattrocento Sans" panose="020B0502050000020003" pitchFamily="34" charset="0"/>
                 <a:ea typeface="QuattrocentoSans" pitchFamily="34" charset="-122"/>
-                <a:cs typeface="QuattrocentoSans" pitchFamily="34" charset="-120"/>
-              </a:rPr>
-              <a:t>Adaptar requisitos</a:t>
-            </a:r>
-            <a:endParaRPr lang="en-US" sz="1800" dirty="0">
-              <a:latin typeface="Quattrocento Sans" panose="020B0502050000020003" pitchFamily="34" charset="0"/>
-            </a:endParaRPr>
+              </a:rPr>
+              <a:t>Anidación de respuestas para el flujo de la conversación</a:t>
+            </a:r>
           </a:p>
           <a:p>
             <a:pPr marL="285750" indent="-285750">
@@ -6081,7 +4958,7 @@
               <a:buChar char="•"/>
             </a:pPr>
             <a:r>
-              <a:rPr lang="en-US" sz="1500" dirty="0">
+              <a:rPr lang="es-ES" sz="1500" noProof="0" dirty="0">
                 <a:solidFill>
                   <a:srgbClr val="212529"/>
                 </a:solidFill>
@@ -6089,9 +4966,9 @@
                 <a:ea typeface="QuattrocentoSans" pitchFamily="34" charset="-122"/>
                 <a:cs typeface="QuattrocentoSans" pitchFamily="34" charset="-120"/>
               </a:rPr>
-              <a:t>Entregar valor incremental</a:t>
-            </a:r>
-            <a:endParaRPr lang="en-US" sz="1800" dirty="0">
+              <a:t>Pre visualización del foro</a:t>
+            </a:r>
+            <a:endParaRPr lang="es-ES" sz="1800" noProof="0" dirty="0">
               <a:latin typeface="Quattrocento Sans" panose="020B0502050000020003" pitchFamily="34" charset="0"/>
             </a:endParaRPr>
           </a:p>
@@ -6111,8 +4988,8 @@
         </p:nvSpPr>
         <p:spPr>
           <a:xfrm>
-            <a:off x="10795000" y="1397000"/>
-            <a:ext cx="4699000" cy="3556000"/>
+            <a:off x="762001" y="1465325"/>
+            <a:ext cx="4699000" cy="3800357"/>
           </a:xfrm>
           <a:prstGeom prst="roundRect">
             <a:avLst>
@@ -6133,7 +5010,7 @@
           <a:bodyPr/>
           <a:lstStyle/>
           <a:p>
-            <a:endParaRPr lang="es-ES">
+            <a:endParaRPr lang="es-ES" noProof="0" dirty="0">
               <a:latin typeface="Quattrocento Sans" panose="020B0502050000020003" pitchFamily="34" charset="0"/>
             </a:endParaRPr>
           </a:p>
@@ -6153,7 +5030,7 @@
         </p:nvSpPr>
         <p:spPr>
           <a:xfrm>
-            <a:off x="11106150" y="1587500"/>
+            <a:off x="1073151" y="1655826"/>
             <a:ext cx="342900" cy="457200"/>
           </a:xfrm>
           <a:custGeom>
@@ -6258,7 +5135,7 @@
           <a:bodyPr/>
           <a:lstStyle/>
           <a:p>
-            <a:endParaRPr lang="es-ES">
+            <a:endParaRPr lang="es-ES" noProof="0" dirty="0">
               <a:latin typeface="Quattrocento Sans" panose="020B0502050000020003" pitchFamily="34" charset="0"/>
             </a:endParaRPr>
           </a:p>
@@ -6278,7 +5155,7 @@
         </p:nvSpPr>
         <p:spPr>
           <a:xfrm>
-            <a:off x="11049000" y="2159000"/>
+            <a:off x="1016001" y="2227326"/>
             <a:ext cx="4191000" cy="381000"/>
           </a:xfrm>
           <a:prstGeom prst="rect">
@@ -6297,7 +5174,7 @@
               </a:lnSpc>
             </a:pPr>
             <a:r>
-              <a:rPr lang="en-US" sz="2000" b="1" dirty="0">
+              <a:rPr lang="es-ES" sz="2000" b="1" noProof="0" dirty="0">
                 <a:solidFill>
                   <a:srgbClr val="1B4332"/>
                 </a:solidFill>
@@ -6305,9 +5182,9 @@
                 <a:ea typeface="Quattrocento Sans" pitchFamily="34" charset="-122"/>
                 <a:cs typeface="Quattrocento Sans" pitchFamily="34" charset="-120"/>
               </a:rPr>
-              <a:t>Mobile-First</a:t>
-            </a:r>
-            <a:endParaRPr lang="en-US" sz="1600" dirty="0">
+              <a:t>Panel de personalización</a:t>
+            </a:r>
+            <a:endParaRPr lang="es-ES" sz="1600" noProof="0" dirty="0">
               <a:latin typeface="Quattrocento Sans" panose="020B0502050000020003" pitchFamily="34" charset="0"/>
             </a:endParaRPr>
           </a:p>
@@ -6327,7 +5204,7 @@
         </p:nvSpPr>
         <p:spPr>
           <a:xfrm>
-            <a:off x="11049000" y="2641600"/>
+            <a:off x="1016001" y="2709926"/>
             <a:ext cx="4191000" cy="2222500"/>
           </a:xfrm>
           <a:prstGeom prst="rect">
@@ -6346,7 +5223,7 @@
               </a:lnSpc>
             </a:pPr>
             <a:r>
-              <a:rPr lang="en-US" sz="1500" dirty="0">
+              <a:rPr lang="es-ES" sz="1500" noProof="0" dirty="0">
                 <a:solidFill>
                   <a:srgbClr val="212529"/>
                 </a:solidFill>
@@ -6354,9 +5231,9 @@
                 <a:ea typeface="QuattrocentoSans" pitchFamily="34" charset="-122"/>
                 <a:cs typeface="QuattrocentoSans" pitchFamily="34" charset="-120"/>
               </a:rPr>
-              <a:t>Desarrollo desde la resolución más baja hacia escritorio.</a:t>
-            </a:r>
-            <a:endParaRPr lang="en-US" sz="1800" dirty="0">
+              <a:t>Función que permite realizar de forma llamativa la difusión del perfil.</a:t>
+            </a:r>
+            <a:endParaRPr lang="es-ES" sz="1800" noProof="0" dirty="0">
               <a:latin typeface="Quattrocento Sans" panose="020B0502050000020003" pitchFamily="34" charset="0"/>
             </a:endParaRPr>
           </a:p>
@@ -6370,7 +5247,7 @@
               </a:spcBef>
             </a:pPr>
             <a:r>
-              <a:rPr lang="en-US" sz="1500" dirty="0">
+              <a:rPr lang="es-ES" sz="1500" noProof="0" dirty="0">
                 <a:solidFill>
                   <a:srgbClr val="212529"/>
                 </a:solidFill>
@@ -6378,9 +5255,9 @@
                 <a:ea typeface="QuattrocentoSans" pitchFamily="34" charset="-122"/>
                 <a:cs typeface="QuattrocentoSans" pitchFamily="34" charset="-120"/>
               </a:rPr>
-              <a:t>Garantiza:</a:t>
-            </a:r>
-            <a:endParaRPr lang="en-US" sz="1800" dirty="0">
+              <a:t>Permite:</a:t>
+            </a:r>
+            <a:endParaRPr lang="es-ES" sz="1800" noProof="0" dirty="0">
               <a:latin typeface="Quattrocento Sans" panose="020B0502050000020003" pitchFamily="34" charset="0"/>
             </a:endParaRPr>
           </a:p>
@@ -6396,19 +5273,15 @@
               <a:buChar char="•"/>
             </a:pPr>
             <a:r>
-              <a:rPr lang="en-US" sz="1500" dirty="0">
+              <a:rPr lang="es-ES" sz="1500" dirty="0">
                 <a:solidFill>
                   <a:srgbClr val="212529"/>
                 </a:solidFill>
                 <a:latin typeface="Quattrocento Sans" panose="020B0502050000020003" pitchFamily="34" charset="0"/>
                 <a:ea typeface="QuattrocentoSans" pitchFamily="34" charset="-122"/>
-                <a:cs typeface="QuattrocentoSans" pitchFamily="34" charset="-120"/>
-              </a:rPr>
-              <a:t>Experiencia óptima en móviles</a:t>
-            </a:r>
-            <a:endParaRPr lang="en-US" sz="1800" dirty="0">
-              <a:latin typeface="Quattrocento Sans" panose="020B0502050000020003" pitchFamily="34" charset="0"/>
-            </a:endParaRPr>
+              </a:rPr>
+              <a:t>Edición dinámica de perfil</a:t>
+            </a:r>
           </a:p>
           <a:p>
             <a:pPr marL="285750" indent="-285750">
@@ -6422,19 +5295,15 @@
               <a:buChar char="•"/>
             </a:pPr>
             <a:r>
-              <a:rPr lang="en-US" sz="1500" dirty="0">
+              <a:rPr lang="es-ES" sz="1500" dirty="0">
                 <a:solidFill>
                   <a:srgbClr val="212529"/>
                 </a:solidFill>
                 <a:latin typeface="Quattrocento Sans" panose="020B0502050000020003" pitchFamily="34" charset="0"/>
                 <a:ea typeface="QuattrocentoSans" pitchFamily="34" charset="-122"/>
-                <a:cs typeface="QuattrocentoSans" pitchFamily="34" charset="-120"/>
-              </a:rPr>
-              <a:t>Progressive enhancement</a:t>
-            </a:r>
-            <a:endParaRPr lang="en-US" sz="1800" dirty="0">
-              <a:latin typeface="Quattrocento Sans" panose="020B0502050000020003" pitchFamily="34" charset="0"/>
-            </a:endParaRPr>
+              </a:rPr>
+              <a:t>Pre visualización en tiempo real de los cambios</a:t>
+            </a:r>
           </a:p>
           <a:p>
             <a:pPr marL="285750" indent="-285750">
@@ -6448,659 +5317,16 @@
               <a:buChar char="•"/>
             </a:pPr>
             <a:r>
-              <a:rPr lang="en-US" sz="1500" dirty="0">
+              <a:rPr lang="es-ES" sz="1500" dirty="0">
                 <a:solidFill>
                   <a:srgbClr val="212529"/>
                 </a:solidFill>
                 <a:latin typeface="Quattrocento Sans" panose="020B0502050000020003" pitchFamily="34" charset="0"/>
                 <a:ea typeface="QuattrocentoSans" pitchFamily="34" charset="-122"/>
-                <a:cs typeface="QuattrocentoSans" pitchFamily="34" charset="-120"/>
-              </a:rPr>
-              <a:t>Mayor cobertura de usuarios</a:t>
-            </a:r>
-            <a:endParaRPr lang="en-US" sz="1800" dirty="0">
-              <a:latin typeface="Quattrocento Sans" panose="020B0502050000020003" pitchFamily="34" charset="0"/>
-            </a:endParaRPr>
-          </a:p>
-        </p:txBody>
-      </p:sp>
-      <p:sp>
-        <p:nvSpPr>
-          <p:cNvPr id="26" name="Shape 24">
-            <a:extLst>
-              <a:ext uri="{FF2B5EF4-FFF2-40B4-BE49-F238E27FC236}">
-                <a16:creationId xmlns:a16="http://schemas.microsoft.com/office/drawing/2014/main" id="{D1BADE1F-915E-D327-2161-C7F20A4ECE4E}"/>
-              </a:ext>
-            </a:extLst>
-          </p:cNvPr>
-          <p:cNvSpPr/>
-          <p:nvPr/>
-        </p:nvSpPr>
-        <p:spPr>
-          <a:xfrm>
-            <a:off x="762000" y="5207000"/>
-            <a:ext cx="14732000" cy="25400"/>
-          </a:xfrm>
-          <a:prstGeom prst="rect">
-            <a:avLst/>
-          </a:prstGeom>
-          <a:solidFill>
-            <a:srgbClr val="E9ECEF"/>
-          </a:solidFill>
-          <a:ln/>
-        </p:spPr>
-        <p:txBody>
-          <a:bodyPr/>
-          <a:lstStyle/>
-          <a:p>
-            <a:endParaRPr lang="es-ES">
-              <a:latin typeface="Quattrocento Sans" panose="020B0502050000020003" pitchFamily="34" charset="0"/>
-            </a:endParaRPr>
-          </a:p>
-        </p:txBody>
-      </p:sp>
-      <p:sp>
-        <p:nvSpPr>
-          <p:cNvPr id="27" name="Text 25">
-            <a:extLst>
-              <a:ext uri="{FF2B5EF4-FFF2-40B4-BE49-F238E27FC236}">
-                <a16:creationId xmlns:a16="http://schemas.microsoft.com/office/drawing/2014/main" id="{F82E9A3A-BE98-A184-729F-FE35F5AFD3EA}"/>
-              </a:ext>
-            </a:extLst>
-          </p:cNvPr>
-          <p:cNvSpPr/>
-          <p:nvPr/>
-        </p:nvSpPr>
-        <p:spPr>
-          <a:xfrm>
-            <a:off x="762000" y="5397500"/>
-            <a:ext cx="5080000" cy="381000"/>
-          </a:xfrm>
-          <a:prstGeom prst="rect">
-            <a:avLst/>
-          </a:prstGeom>
-          <a:noFill/>
-          <a:ln/>
-        </p:spPr>
-        <p:txBody>
-          <a:bodyPr wrap="none" lIns="0" tIns="0" rIns="0" bIns="0" rtlCol="0" anchor="ctr"/>
-          <a:lstStyle/>
-          <a:p>
-            <a:pPr>
-              <a:lnSpc>
-                <a:spcPct val="140000"/>
-              </a:lnSpc>
-            </a:pPr>
-            <a:r>
-              <a:rPr lang="en-US" sz="2000" b="1" dirty="0">
-                <a:solidFill>
-                  <a:srgbClr val="6C757D"/>
-                </a:solidFill>
-                <a:latin typeface="Quattrocento Sans" panose="020B0502050000020003" pitchFamily="34" charset="0"/>
-                <a:ea typeface="QuattrocentoSans" pitchFamily="34" charset="-122"/>
-                <a:cs typeface="QuattrocentoSans" pitchFamily="34" charset="-120"/>
-              </a:rPr>
-              <a:t>Stack Tecnológico</a:t>
-            </a:r>
-            <a:endParaRPr lang="en-US" sz="2000" dirty="0">
-              <a:latin typeface="Quattrocento Sans" panose="020B0502050000020003" pitchFamily="34" charset="0"/>
-            </a:endParaRPr>
-          </a:p>
-        </p:txBody>
-      </p:sp>
-      <p:sp>
-        <p:nvSpPr>
-          <p:cNvPr id="28" name="Shape 26">
-            <a:extLst>
-              <a:ext uri="{FF2B5EF4-FFF2-40B4-BE49-F238E27FC236}">
-                <a16:creationId xmlns:a16="http://schemas.microsoft.com/office/drawing/2014/main" id="{90720BDE-0B4F-91A6-FF82-5F17295E923C}"/>
-              </a:ext>
-            </a:extLst>
-          </p:cNvPr>
-          <p:cNvSpPr/>
-          <p:nvPr/>
-        </p:nvSpPr>
-        <p:spPr>
-          <a:xfrm>
-            <a:off x="762000" y="5969000"/>
-            <a:ext cx="1651000" cy="457200"/>
-          </a:xfrm>
-          <a:prstGeom prst="roundRect">
-            <a:avLst>
-              <a:gd name="adj" fmla="val 16000"/>
-            </a:avLst>
-          </a:prstGeom>
-          <a:solidFill>
-            <a:srgbClr val="1B4332"/>
-          </a:solidFill>
-          <a:ln/>
-        </p:spPr>
-        <p:txBody>
-          <a:bodyPr/>
-          <a:lstStyle/>
-          <a:p>
-            <a:endParaRPr lang="es-ES">
-              <a:latin typeface="Quattrocento Sans" panose="020B0502050000020003" pitchFamily="34" charset="0"/>
-            </a:endParaRPr>
-          </a:p>
-        </p:txBody>
-      </p:sp>
-      <p:sp>
-        <p:nvSpPr>
-          <p:cNvPr id="29" name="Text 27">
-            <a:extLst>
-              <a:ext uri="{FF2B5EF4-FFF2-40B4-BE49-F238E27FC236}">
-                <a16:creationId xmlns:a16="http://schemas.microsoft.com/office/drawing/2014/main" id="{762662A7-EEAE-D014-6C6B-463512DCD557}"/>
-              </a:ext>
-            </a:extLst>
-          </p:cNvPr>
-          <p:cNvSpPr/>
-          <p:nvPr/>
-        </p:nvSpPr>
-        <p:spPr>
-          <a:xfrm>
-            <a:off x="762000" y="5969000"/>
-            <a:ext cx="1651000" cy="457200"/>
-          </a:xfrm>
-          <a:prstGeom prst="rect">
-            <a:avLst/>
-          </a:prstGeom>
-          <a:noFill/>
-          <a:ln/>
-        </p:spPr>
-        <p:txBody>
-          <a:bodyPr wrap="none" lIns="0" tIns="0" rIns="0" bIns="0" rtlCol="0" anchor="ctr"/>
-          <a:lstStyle/>
-          <a:p>
-            <a:pPr algn="ctr">
-              <a:lnSpc>
-                <a:spcPct val="100000"/>
-              </a:lnSpc>
-            </a:pPr>
-            <a:r>
-              <a:rPr lang="en-US" sz="1400" b="1" dirty="0">
-                <a:solidFill>
-                  <a:srgbClr val="FFFFFF"/>
-                </a:solidFill>
-                <a:latin typeface="Quattrocento Sans" panose="020B0502050000020003" pitchFamily="34" charset="0"/>
-                <a:ea typeface="QuattrocentoSans" pitchFamily="34" charset="-122"/>
-                <a:cs typeface="QuattrocentoSans" pitchFamily="34" charset="-120"/>
-              </a:rPr>
-              <a:t>React</a:t>
-            </a:r>
-            <a:endParaRPr lang="en-US" sz="1400" dirty="0">
-              <a:latin typeface="Quattrocento Sans" panose="020B0502050000020003" pitchFamily="34" charset="0"/>
-            </a:endParaRPr>
-          </a:p>
-        </p:txBody>
-      </p:sp>
-      <p:sp>
-        <p:nvSpPr>
-          <p:cNvPr id="30" name="Shape 28">
-            <a:extLst>
-              <a:ext uri="{FF2B5EF4-FFF2-40B4-BE49-F238E27FC236}">
-                <a16:creationId xmlns:a16="http://schemas.microsoft.com/office/drawing/2014/main" id="{BC937F96-271C-8D96-61CD-98CD22001879}"/>
-              </a:ext>
-            </a:extLst>
-          </p:cNvPr>
-          <p:cNvSpPr/>
-          <p:nvPr/>
-        </p:nvSpPr>
-        <p:spPr>
-          <a:xfrm>
-            <a:off x="2603500" y="5969000"/>
-            <a:ext cx="2286000" cy="457200"/>
-          </a:xfrm>
-          <a:prstGeom prst="roundRect">
-            <a:avLst>
-              <a:gd name="adj" fmla="val 16000"/>
-            </a:avLst>
-          </a:prstGeom>
-          <a:solidFill>
-            <a:srgbClr val="1B4332"/>
-          </a:solidFill>
-          <a:ln/>
-        </p:spPr>
-        <p:txBody>
-          <a:bodyPr/>
-          <a:lstStyle/>
-          <a:p>
-            <a:endParaRPr lang="es-ES">
-              <a:latin typeface="Quattrocento Sans" panose="020B0502050000020003" pitchFamily="34" charset="0"/>
-            </a:endParaRPr>
-          </a:p>
-        </p:txBody>
-      </p:sp>
-      <p:sp>
-        <p:nvSpPr>
-          <p:cNvPr id="31" name="Text 29">
-            <a:extLst>
-              <a:ext uri="{FF2B5EF4-FFF2-40B4-BE49-F238E27FC236}">
-                <a16:creationId xmlns:a16="http://schemas.microsoft.com/office/drawing/2014/main" id="{AF02A601-2B00-D1D7-3709-EA4565A33B18}"/>
-              </a:ext>
-            </a:extLst>
-          </p:cNvPr>
-          <p:cNvSpPr/>
-          <p:nvPr/>
-        </p:nvSpPr>
-        <p:spPr>
-          <a:xfrm>
-            <a:off x="2603500" y="5969000"/>
-            <a:ext cx="2286000" cy="457200"/>
-          </a:xfrm>
-          <a:prstGeom prst="rect">
-            <a:avLst/>
-          </a:prstGeom>
-          <a:noFill/>
-          <a:ln/>
-        </p:spPr>
-        <p:txBody>
-          <a:bodyPr wrap="none" lIns="0" tIns="0" rIns="0" bIns="0" rtlCol="0" anchor="ctr"/>
-          <a:lstStyle/>
-          <a:p>
-            <a:pPr algn="ctr">
-              <a:lnSpc>
-                <a:spcPct val="100000"/>
-              </a:lnSpc>
-            </a:pPr>
-            <a:r>
-              <a:rPr lang="en-US" sz="1400" b="1" dirty="0">
-                <a:solidFill>
-                  <a:srgbClr val="FFFFFF"/>
-                </a:solidFill>
-                <a:latin typeface="Quattrocento Sans" panose="020B0502050000020003" pitchFamily="34" charset="0"/>
-                <a:ea typeface="QuattrocentoSans" pitchFamily="34" charset="-122"/>
-                <a:cs typeface="QuattrocentoSans" pitchFamily="34" charset="-120"/>
-              </a:rPr>
-              <a:t>Node.js</a:t>
-            </a:r>
-            <a:endParaRPr lang="en-US" sz="1400" dirty="0">
-              <a:latin typeface="Quattrocento Sans" panose="020B0502050000020003" pitchFamily="34" charset="0"/>
-            </a:endParaRPr>
-          </a:p>
-        </p:txBody>
-      </p:sp>
-      <p:sp>
-        <p:nvSpPr>
-          <p:cNvPr id="32" name="Shape 30">
-            <a:extLst>
-              <a:ext uri="{FF2B5EF4-FFF2-40B4-BE49-F238E27FC236}">
-                <a16:creationId xmlns:a16="http://schemas.microsoft.com/office/drawing/2014/main" id="{46B9323D-4B70-7417-06E7-26C63E36DED5}"/>
-              </a:ext>
-            </a:extLst>
-          </p:cNvPr>
-          <p:cNvSpPr/>
-          <p:nvPr/>
-        </p:nvSpPr>
-        <p:spPr>
-          <a:xfrm>
-            <a:off x="5080000" y="5969000"/>
-            <a:ext cx="1778000" cy="457200"/>
-          </a:xfrm>
-          <a:prstGeom prst="roundRect">
-            <a:avLst>
-              <a:gd name="adj" fmla="val 16000"/>
-            </a:avLst>
-          </a:prstGeom>
-          <a:solidFill>
-            <a:srgbClr val="1B4332"/>
-          </a:solidFill>
-          <a:ln/>
-        </p:spPr>
-        <p:txBody>
-          <a:bodyPr/>
-          <a:lstStyle/>
-          <a:p>
-            <a:endParaRPr lang="es-ES">
-              <a:latin typeface="Quattrocento Sans" panose="020B0502050000020003" pitchFamily="34" charset="0"/>
-            </a:endParaRPr>
-          </a:p>
-        </p:txBody>
-      </p:sp>
-      <p:sp>
-        <p:nvSpPr>
-          <p:cNvPr id="33" name="Text 31">
-            <a:extLst>
-              <a:ext uri="{FF2B5EF4-FFF2-40B4-BE49-F238E27FC236}">
-                <a16:creationId xmlns:a16="http://schemas.microsoft.com/office/drawing/2014/main" id="{5D8C4A49-7EBD-6B52-F108-74C7785B6431}"/>
-              </a:ext>
-            </a:extLst>
-          </p:cNvPr>
-          <p:cNvSpPr/>
-          <p:nvPr/>
-        </p:nvSpPr>
-        <p:spPr>
-          <a:xfrm>
-            <a:off x="5080000" y="5969000"/>
-            <a:ext cx="1778000" cy="457200"/>
-          </a:xfrm>
-          <a:prstGeom prst="rect">
-            <a:avLst/>
-          </a:prstGeom>
-          <a:noFill/>
-          <a:ln/>
-        </p:spPr>
-        <p:txBody>
-          <a:bodyPr wrap="none" lIns="0" tIns="0" rIns="0" bIns="0" rtlCol="0" anchor="ctr"/>
-          <a:lstStyle/>
-          <a:p>
-            <a:pPr algn="ctr">
-              <a:lnSpc>
-                <a:spcPct val="100000"/>
-              </a:lnSpc>
-            </a:pPr>
-            <a:r>
-              <a:rPr lang="en-US" sz="1400" b="1" dirty="0">
-                <a:solidFill>
-                  <a:srgbClr val="FFFFFF"/>
-                </a:solidFill>
-                <a:latin typeface="Quattrocento Sans" panose="020B0502050000020003" pitchFamily="34" charset="0"/>
-                <a:ea typeface="QuattrocentoSans" pitchFamily="34" charset="-122"/>
-                <a:cs typeface="QuattrocentoSans" pitchFamily="34" charset="-120"/>
-              </a:rPr>
-              <a:t>PostgreSQL</a:t>
-            </a:r>
-            <a:endParaRPr lang="en-US" sz="1400" dirty="0">
-              <a:latin typeface="Quattrocento Sans" panose="020B0502050000020003" pitchFamily="34" charset="0"/>
-            </a:endParaRPr>
-          </a:p>
-        </p:txBody>
-      </p:sp>
-      <p:sp>
-        <p:nvSpPr>
-          <p:cNvPr id="34" name="Shape 32">
-            <a:extLst>
-              <a:ext uri="{FF2B5EF4-FFF2-40B4-BE49-F238E27FC236}">
-                <a16:creationId xmlns:a16="http://schemas.microsoft.com/office/drawing/2014/main" id="{95E36640-A313-7741-2EA8-7030AAD717FF}"/>
-              </a:ext>
-            </a:extLst>
-          </p:cNvPr>
-          <p:cNvSpPr/>
-          <p:nvPr/>
-        </p:nvSpPr>
-        <p:spPr>
-          <a:xfrm>
-            <a:off x="7048500" y="5969000"/>
-            <a:ext cx="1651000" cy="457200"/>
-          </a:xfrm>
-          <a:prstGeom prst="roundRect">
-            <a:avLst>
-              <a:gd name="adj" fmla="val 16000"/>
-            </a:avLst>
-          </a:prstGeom>
-          <a:solidFill>
-            <a:srgbClr val="1B4332"/>
-          </a:solidFill>
-          <a:ln/>
-        </p:spPr>
-        <p:txBody>
-          <a:bodyPr/>
-          <a:lstStyle/>
-          <a:p>
-            <a:endParaRPr lang="es-ES">
-              <a:latin typeface="Quattrocento Sans" panose="020B0502050000020003" pitchFamily="34" charset="0"/>
-            </a:endParaRPr>
-          </a:p>
-        </p:txBody>
-      </p:sp>
-      <p:sp>
-        <p:nvSpPr>
-          <p:cNvPr id="35" name="Text 33">
-            <a:extLst>
-              <a:ext uri="{FF2B5EF4-FFF2-40B4-BE49-F238E27FC236}">
-                <a16:creationId xmlns:a16="http://schemas.microsoft.com/office/drawing/2014/main" id="{E78CE0DE-FD54-D6A3-A2EC-918E700B44E9}"/>
-              </a:ext>
-            </a:extLst>
-          </p:cNvPr>
-          <p:cNvSpPr/>
-          <p:nvPr/>
-        </p:nvSpPr>
-        <p:spPr>
-          <a:xfrm>
-            <a:off x="7048500" y="5969000"/>
-            <a:ext cx="1651000" cy="457200"/>
-          </a:xfrm>
-          <a:prstGeom prst="rect">
-            <a:avLst/>
-          </a:prstGeom>
-          <a:noFill/>
-          <a:ln/>
-        </p:spPr>
-        <p:txBody>
-          <a:bodyPr wrap="none" lIns="0" tIns="0" rIns="0" bIns="0" rtlCol="0" anchor="ctr"/>
-          <a:lstStyle/>
-          <a:p>
-            <a:pPr algn="ctr">
-              <a:lnSpc>
-                <a:spcPct val="100000"/>
-              </a:lnSpc>
-            </a:pPr>
-            <a:r>
-              <a:rPr lang="en-US" sz="1400" b="1" dirty="0">
-                <a:solidFill>
-                  <a:srgbClr val="FFFFFF"/>
-                </a:solidFill>
-                <a:latin typeface="Quattrocento Sans" panose="020B0502050000020003" pitchFamily="34" charset="0"/>
-                <a:ea typeface="QuattrocentoSans" pitchFamily="34" charset="-122"/>
-                <a:cs typeface="QuattrocentoSans" pitchFamily="34" charset="-120"/>
-              </a:rPr>
-              <a:t>Docker</a:t>
-            </a:r>
-            <a:endParaRPr lang="en-US" sz="1400" dirty="0">
-              <a:latin typeface="Quattrocento Sans" panose="020B0502050000020003" pitchFamily="34" charset="0"/>
-            </a:endParaRPr>
-          </a:p>
-        </p:txBody>
-      </p:sp>
-      <p:sp>
-        <p:nvSpPr>
-          <p:cNvPr id="36" name="Text 34">
-            <a:extLst>
-              <a:ext uri="{FF2B5EF4-FFF2-40B4-BE49-F238E27FC236}">
-                <a16:creationId xmlns:a16="http://schemas.microsoft.com/office/drawing/2014/main" id="{8B84F229-985D-F0F4-7E8B-46CA9100DB30}"/>
-              </a:ext>
-            </a:extLst>
-          </p:cNvPr>
-          <p:cNvSpPr/>
-          <p:nvPr/>
-        </p:nvSpPr>
-        <p:spPr>
-          <a:xfrm>
-            <a:off x="762000" y="6667500"/>
-            <a:ext cx="14732000" cy="1651000"/>
-          </a:xfrm>
-          <a:prstGeom prst="rect">
-            <a:avLst/>
-          </a:prstGeom>
-          <a:noFill/>
-          <a:ln/>
-        </p:spPr>
-        <p:txBody>
-          <a:bodyPr wrap="square" lIns="0" tIns="0" rIns="0" bIns="0" rtlCol="0" anchor="t"/>
-          <a:lstStyle/>
-          <a:p>
-            <a:pPr>
-              <a:lnSpc>
-                <a:spcPct val="150000"/>
-              </a:lnSpc>
-            </a:pPr>
-            <a:r>
-              <a:rPr lang="en-US" sz="1600" b="1" dirty="0">
-                <a:solidFill>
-                  <a:srgbClr val="212529"/>
-                </a:solidFill>
-                <a:latin typeface="Quattrocento Sans" panose="020B0502050000020003" pitchFamily="34" charset="0"/>
-                <a:ea typeface="QuattrocentoSans" pitchFamily="34" charset="-122"/>
-                <a:cs typeface="QuattrocentoSans" pitchFamily="34" charset="-120"/>
-              </a:rPr>
-              <a:t>Frontend:</a:t>
-            </a:r>
-            <a:r>
-              <a:rPr lang="en-US" sz="1600" dirty="0">
-                <a:solidFill>
-                  <a:srgbClr val="212529"/>
-                </a:solidFill>
-                <a:latin typeface="Quattrocento Sans" panose="020B0502050000020003" pitchFamily="34" charset="0"/>
-                <a:ea typeface="QuattrocentoSans" pitchFamily="34" charset="-122"/>
-                <a:cs typeface="QuattrocentoSans" pitchFamily="34" charset="-120"/>
-              </a:rPr>
-              <a:t> React + Vite — SPA de alto rendimiento con componentes reutilizables.</a:t>
-            </a:r>
-            <a:endParaRPr lang="en-US" sz="1800" dirty="0">
-              <a:latin typeface="Quattrocento Sans" panose="020B0502050000020003" pitchFamily="34" charset="0"/>
-            </a:endParaRPr>
-          </a:p>
-          <a:p>
-            <a:pPr>
-              <a:lnSpc>
-                <a:spcPct val="150000"/>
-              </a:lnSpc>
-              <a:spcBef>
-                <a:spcPts val="400"/>
-              </a:spcBef>
-            </a:pPr>
-            <a:r>
-              <a:rPr lang="en-US" sz="1600" b="1" dirty="0">
-                <a:solidFill>
-                  <a:srgbClr val="212529"/>
-                </a:solidFill>
-                <a:latin typeface="Quattrocento Sans" panose="020B0502050000020003" pitchFamily="34" charset="0"/>
-                <a:ea typeface="QuattrocentoSans" pitchFamily="34" charset="-122"/>
-                <a:cs typeface="QuattrocentoSans" pitchFamily="34" charset="-120"/>
-              </a:rPr>
-              <a:t>Backend:</a:t>
-            </a:r>
-            <a:r>
-              <a:rPr lang="en-US" sz="1600" dirty="0">
-                <a:solidFill>
-                  <a:srgbClr val="212529"/>
-                </a:solidFill>
-                <a:latin typeface="Quattrocento Sans" panose="020B0502050000020003" pitchFamily="34" charset="0"/>
-                <a:ea typeface="QuattrocentoSans" pitchFamily="34" charset="-122"/>
-                <a:cs typeface="QuattrocentoSans" pitchFamily="34" charset="-120"/>
-              </a:rPr>
-              <a:t> Node.js + Express.js — arquitectura ligera y escalable con eventos asíncronos.</a:t>
-            </a:r>
-            <a:endParaRPr lang="en-US" sz="1800" dirty="0">
-              <a:latin typeface="Quattrocento Sans" panose="020B0502050000020003" pitchFamily="34" charset="0"/>
-            </a:endParaRPr>
-          </a:p>
-          <a:p>
-            <a:pPr>
-              <a:lnSpc>
-                <a:spcPct val="150000"/>
-              </a:lnSpc>
-              <a:spcBef>
-                <a:spcPts val="400"/>
-              </a:spcBef>
-            </a:pPr>
-            <a:r>
-              <a:rPr lang="en-US" sz="1600" b="1" dirty="0">
-                <a:solidFill>
-                  <a:srgbClr val="212529"/>
-                </a:solidFill>
-                <a:latin typeface="Quattrocento Sans" panose="020B0502050000020003" pitchFamily="34" charset="0"/>
-                <a:ea typeface="QuattrocentoSans" pitchFamily="34" charset="-122"/>
-                <a:cs typeface="QuattrocentoSans" pitchFamily="34" charset="-120"/>
-              </a:rPr>
-              <a:t>Base de datos:</a:t>
-            </a:r>
-            <a:r>
-              <a:rPr lang="en-US" sz="1600" dirty="0">
-                <a:solidFill>
-                  <a:srgbClr val="212529"/>
-                </a:solidFill>
-                <a:latin typeface="Quattrocento Sans" panose="020B0502050000020003" pitchFamily="34" charset="0"/>
-                <a:ea typeface="QuattrocentoSans" pitchFamily="34" charset="-122"/>
-                <a:cs typeface="QuattrocentoSans" pitchFamily="34" charset="-120"/>
-              </a:rPr>
-              <a:t> PostgreSQL— modelo relacional robusto con migraciones automáticas.</a:t>
-            </a:r>
-            <a:endParaRPr lang="en-US" sz="1800" dirty="0">
-              <a:latin typeface="Quattrocento Sans" panose="020B0502050000020003" pitchFamily="34" charset="0"/>
-            </a:endParaRPr>
-          </a:p>
-          <a:p>
-            <a:pPr>
-              <a:lnSpc>
-                <a:spcPct val="150000"/>
-              </a:lnSpc>
-              <a:spcBef>
-                <a:spcPts val="400"/>
-              </a:spcBef>
-            </a:pPr>
-            <a:r>
-              <a:rPr lang="en-US" sz="1600" b="1" dirty="0">
-                <a:solidFill>
-                  <a:srgbClr val="212529"/>
-                </a:solidFill>
-                <a:latin typeface="Quattrocento Sans" panose="020B0502050000020003" pitchFamily="34" charset="0"/>
-                <a:ea typeface="QuattrocentoSans" pitchFamily="34" charset="-122"/>
-                <a:cs typeface="QuattrocentoSans" pitchFamily="34" charset="-120"/>
-              </a:rPr>
-              <a:t>Despliegue:</a:t>
-            </a:r>
-            <a:r>
-              <a:rPr lang="en-US" sz="1600" dirty="0">
-                <a:solidFill>
-                  <a:srgbClr val="212529"/>
-                </a:solidFill>
-                <a:latin typeface="Quattrocento Sans" panose="020B0502050000020003" pitchFamily="34" charset="0"/>
-                <a:ea typeface="QuattrocentoSans" pitchFamily="34" charset="-122"/>
-                <a:cs typeface="QuattrocentoSans" pitchFamily="34" charset="-120"/>
-              </a:rPr>
-              <a:t> Docker + Nginx — contenedores para entornos idénticos y proxy inverso.</a:t>
-            </a:r>
-            <a:endParaRPr lang="en-US" sz="1800" dirty="0">
-              <a:latin typeface="Quattrocento Sans" panose="020B0502050000020003" pitchFamily="34" charset="0"/>
-            </a:endParaRPr>
-          </a:p>
-        </p:txBody>
-      </p:sp>
-      <p:sp>
-        <p:nvSpPr>
-          <p:cNvPr id="37" name="Text 35">
-            <a:extLst>
-              <a:ext uri="{FF2B5EF4-FFF2-40B4-BE49-F238E27FC236}">
-                <a16:creationId xmlns:a16="http://schemas.microsoft.com/office/drawing/2014/main" id="{D689B158-AFB7-D6A3-83CB-57E6F662CC12}"/>
-              </a:ext>
-            </a:extLst>
-          </p:cNvPr>
-          <p:cNvSpPr/>
-          <p:nvPr/>
-        </p:nvSpPr>
-        <p:spPr>
-          <a:xfrm>
-            <a:off x="15240000" y="8763000"/>
-            <a:ext cx="762000" cy="254000"/>
-          </a:xfrm>
-          <a:prstGeom prst="rect">
-            <a:avLst/>
-          </a:prstGeom>
-          <a:noFill/>
-          <a:ln/>
-        </p:spPr>
-        <p:txBody>
-          <a:bodyPr wrap="none" lIns="0" tIns="0" rIns="0" bIns="0" rtlCol="0" anchor="ctr"/>
-          <a:lstStyle/>
-          <a:p>
-            <a:pPr algn="r">
-              <a:lnSpc>
-                <a:spcPct val="140000"/>
-              </a:lnSpc>
-            </a:pPr>
-            <a:r>
-              <a:rPr lang="en-US" sz="1400" dirty="0">
-                <a:solidFill>
-                  <a:srgbClr val="6C757D"/>
-                </a:solidFill>
-                <a:latin typeface="Quattrocento Sans" panose="020B0502050000020003" pitchFamily="34" charset="0"/>
-                <a:ea typeface="QuattrocentoSans" pitchFamily="34" charset="-122"/>
-                <a:cs typeface="QuattrocentoSans" pitchFamily="34" charset="-120"/>
-              </a:rPr>
-              <a:t>3 / 10</a:t>
-            </a:r>
-            <a:endParaRPr lang="en-US" sz="1400" dirty="0">
+              </a:rPr>
+              <a:t>Gestión de perfiles minimalistas</a:t>
+            </a:r>
+            <a:endParaRPr lang="es-ES" sz="1800" noProof="0" dirty="0">
               <a:latin typeface="Quattrocento Sans" panose="020B0502050000020003" pitchFamily="34" charset="0"/>
             </a:endParaRPr>
           </a:p>
@@ -7153,6 +5379,251 @@
           </a:extLst>
         </p:spPr>
       </p:pic>
+      <p:pic>
+        <p:nvPicPr>
+          <p:cNvPr id="4" name="Imagen 3">
+            <a:extLst>
+              <a:ext uri="{FF2B5EF4-FFF2-40B4-BE49-F238E27FC236}">
+                <a16:creationId xmlns:a16="http://schemas.microsoft.com/office/drawing/2014/main" id="{357935D0-5389-AA24-4DB0-D9D2AE0DB672}"/>
+              </a:ext>
+            </a:extLst>
+          </p:cNvPr>
+          <p:cNvPicPr>
+            <a:picLocks noChangeAspect="1"/>
+          </p:cNvPicPr>
+          <p:nvPr/>
+        </p:nvPicPr>
+        <p:blipFill>
+          <a:blip r:embed="rId4"/>
+          <a:stretch>
+            <a:fillRect/>
+          </a:stretch>
+        </p:blipFill>
+        <p:spPr>
+          <a:xfrm>
+            <a:off x="5981700" y="1567404"/>
+            <a:ext cx="604141" cy="604141"/>
+          </a:xfrm>
+          <a:prstGeom prst="rect">
+            <a:avLst/>
+          </a:prstGeom>
+        </p:spPr>
+      </p:pic>
+      <p:pic>
+        <p:nvPicPr>
+          <p:cNvPr id="7" name="Imagen 6">
+            <a:extLst>
+              <a:ext uri="{FF2B5EF4-FFF2-40B4-BE49-F238E27FC236}">
+                <a16:creationId xmlns:a16="http://schemas.microsoft.com/office/drawing/2014/main" id="{A65DE619-6814-A97E-44FF-0D48A3702672}"/>
+              </a:ext>
+            </a:extLst>
+          </p:cNvPr>
+          <p:cNvPicPr>
+            <a:picLocks noChangeAspect="1"/>
+          </p:cNvPicPr>
+          <p:nvPr/>
+        </p:nvPicPr>
+        <p:blipFill>
+          <a:blip r:embed="rId5"/>
+          <a:stretch>
+            <a:fillRect/>
+          </a:stretch>
+        </p:blipFill>
+        <p:spPr>
+          <a:xfrm>
+            <a:off x="812800" y="5555982"/>
+            <a:ext cx="4691424" cy="2582665"/>
+          </a:xfrm>
+          <a:prstGeom prst="roundRect">
+            <a:avLst>
+              <a:gd name="adj" fmla="val 8594"/>
+            </a:avLst>
+          </a:prstGeom>
+          <a:solidFill>
+            <a:srgbClr val="FFFFFF">
+              <a:shade val="85000"/>
+            </a:srgbClr>
+          </a:solidFill>
+          <a:ln>
+            <a:noFill/>
+          </a:ln>
+          <a:effectLst/>
+        </p:spPr>
+      </p:pic>
+      <p:pic>
+        <p:nvPicPr>
+          <p:cNvPr id="11" name="Imagen 10">
+            <a:extLst>
+              <a:ext uri="{FF2B5EF4-FFF2-40B4-BE49-F238E27FC236}">
+                <a16:creationId xmlns:a16="http://schemas.microsoft.com/office/drawing/2014/main" id="{59822640-136E-B4B7-423B-3041FADA03AD}"/>
+              </a:ext>
+            </a:extLst>
+          </p:cNvPr>
+          <p:cNvPicPr>
+            <a:picLocks noChangeAspect="1"/>
+          </p:cNvPicPr>
+          <p:nvPr/>
+        </p:nvPicPr>
+        <p:blipFill>
+          <a:blip r:embed="rId6"/>
+          <a:stretch>
+            <a:fillRect/>
+          </a:stretch>
+        </p:blipFill>
+        <p:spPr>
+          <a:xfrm>
+            <a:off x="10794999" y="5720693"/>
+            <a:ext cx="4699000" cy="2149658"/>
+          </a:xfrm>
+          <a:prstGeom prst="roundRect">
+            <a:avLst>
+              <a:gd name="adj" fmla="val 8594"/>
+            </a:avLst>
+          </a:prstGeom>
+          <a:solidFill>
+            <a:srgbClr val="FFFFFF">
+              <a:shade val="85000"/>
+            </a:srgbClr>
+          </a:solidFill>
+          <a:ln>
+            <a:noFill/>
+          </a:ln>
+          <a:effectLst/>
+        </p:spPr>
+      </p:pic>
+      <p:pic>
+        <p:nvPicPr>
+          <p:cNvPr id="39" name="Imagen 38">
+            <a:extLst>
+              <a:ext uri="{FF2B5EF4-FFF2-40B4-BE49-F238E27FC236}">
+                <a16:creationId xmlns:a16="http://schemas.microsoft.com/office/drawing/2014/main" id="{38741A87-C787-ED10-358E-396F3C12F315}"/>
+              </a:ext>
+            </a:extLst>
+          </p:cNvPr>
+          <p:cNvPicPr>
+            <a:picLocks noChangeAspect="1"/>
+          </p:cNvPicPr>
+          <p:nvPr/>
+        </p:nvPicPr>
+        <p:blipFill>
+          <a:blip r:embed="rId7"/>
+          <a:srcRect t="53500" b="1124"/>
+          <a:stretch>
+            <a:fillRect/>
+          </a:stretch>
+        </p:blipFill>
+        <p:spPr>
+          <a:xfrm>
+            <a:off x="8376790" y="5690498"/>
+            <a:ext cx="1957989" cy="2179853"/>
+          </a:xfrm>
+          <a:prstGeom prst="roundRect">
+            <a:avLst>
+              <a:gd name="adj" fmla="val 8594"/>
+            </a:avLst>
+          </a:prstGeom>
+          <a:solidFill>
+            <a:srgbClr val="FFFFFF">
+              <a:shade val="85000"/>
+            </a:srgbClr>
+          </a:solidFill>
+          <a:ln>
+            <a:noFill/>
+          </a:ln>
+          <a:effectLst/>
+        </p:spPr>
+      </p:pic>
+      <p:pic>
+        <p:nvPicPr>
+          <p:cNvPr id="40" name="Imagen 39">
+            <a:extLst>
+              <a:ext uri="{FF2B5EF4-FFF2-40B4-BE49-F238E27FC236}">
+                <a16:creationId xmlns:a16="http://schemas.microsoft.com/office/drawing/2014/main" id="{DB560947-DFC3-0586-198A-82D0158DA1DC}"/>
+              </a:ext>
+            </a:extLst>
+          </p:cNvPr>
+          <p:cNvPicPr>
+            <a:picLocks noChangeAspect="1"/>
+          </p:cNvPicPr>
+          <p:nvPr/>
+        </p:nvPicPr>
+        <p:blipFill>
+          <a:blip r:embed="rId7"/>
+          <a:srcRect b="46499"/>
+          <a:stretch>
+            <a:fillRect/>
+          </a:stretch>
+        </p:blipFill>
+        <p:spPr>
+          <a:xfrm>
+            <a:off x="6108356" y="5608740"/>
+            <a:ext cx="1808214" cy="2373563"/>
+          </a:xfrm>
+          <a:prstGeom prst="roundRect">
+            <a:avLst>
+              <a:gd name="adj" fmla="val 8594"/>
+            </a:avLst>
+          </a:prstGeom>
+          <a:solidFill>
+            <a:srgbClr val="FFFFFF">
+              <a:shade val="85000"/>
+            </a:srgbClr>
+          </a:solidFill>
+          <a:ln>
+            <a:noFill/>
+          </a:ln>
+          <a:effectLst/>
+        </p:spPr>
+      </p:pic>
+      <p:sp>
+        <p:nvSpPr>
+          <p:cNvPr id="6" name="Text 35">
+            <a:extLst>
+              <a:ext uri="{FF2B5EF4-FFF2-40B4-BE49-F238E27FC236}">
+                <a16:creationId xmlns:a16="http://schemas.microsoft.com/office/drawing/2014/main" id="{9ED91221-F816-5B74-8EB0-34164E843238}"/>
+              </a:ext>
+            </a:extLst>
+          </p:cNvPr>
+          <p:cNvSpPr/>
+          <p:nvPr/>
+        </p:nvSpPr>
+        <p:spPr>
+          <a:xfrm>
+            <a:off x="15240000" y="8763000"/>
+            <a:ext cx="762000" cy="254000"/>
+          </a:xfrm>
+          <a:prstGeom prst="rect">
+            <a:avLst/>
+          </a:prstGeom>
+          <a:noFill/>
+          <a:ln/>
+        </p:spPr>
+        <p:txBody>
+          <a:bodyPr wrap="none" lIns="0" tIns="0" rIns="0" bIns="0" rtlCol="0" anchor="ctr"/>
+          <a:lstStyle/>
+          <a:p>
+            <a:pPr algn="r">
+              <a:lnSpc>
+                <a:spcPct val="140000"/>
+              </a:lnSpc>
+            </a:pPr>
+            <a:r>
+              <a:rPr lang="es-ES" sz="1400" noProof="0" dirty="0">
+                <a:solidFill>
+                  <a:srgbClr val="6C757D"/>
+                </a:solidFill>
+                <a:latin typeface="Quattrocento Sans" panose="020B0502050000020003" pitchFamily="34" charset="0"/>
+                <a:ea typeface="QuattrocentoSans" pitchFamily="34" charset="-122"/>
+                <a:cs typeface="QuattrocentoSans" pitchFamily="34" charset="-120"/>
+              </a:rPr>
+              <a:t>11 / 12</a:t>
+            </a:r>
+            <a:endParaRPr lang="es-ES" sz="1400" noProof="0" dirty="0">
+              <a:latin typeface="Quattrocento Sans" panose="020B0502050000020003" pitchFamily="34" charset="0"/>
+            </a:endParaRPr>
+          </a:p>
+        </p:txBody>
+      </p:sp>
     </p:spTree>
     <p:extLst>
       <p:ext uri="{BB962C8B-B14F-4D97-AF65-F5344CB8AC3E}">
@@ -10271,7 +8742,7 @@
                 <a:ea typeface="QuattrocentoSans" pitchFamily="34" charset="-122"/>
                 <a:cs typeface="QuattrocentoSans" pitchFamily="34" charset="-120"/>
               </a:rPr>
-              <a:t>2 / 10</a:t>
+              <a:t>2 / 12</a:t>
             </a:r>
             <a:endParaRPr lang="en-US" sz="1400" dirty="0">
               <a:latin typeface="Quattrocento Sans" panose="020B0502050000020003" pitchFamily="34" charset="0"/>
@@ -12283,7 +10754,7 @@
                 <a:ea typeface="QuattrocentoSans" pitchFamily="34" charset="-122"/>
                 <a:cs typeface="QuattrocentoSans" pitchFamily="34" charset="-120"/>
               </a:rPr>
-              <a:t>3 / 10</a:t>
+              <a:t>3 / 12</a:t>
             </a:r>
             <a:endParaRPr lang="en-US" sz="1400" dirty="0">
               <a:latin typeface="Quattrocento Sans" panose="020B0502050000020003" pitchFamily="34" charset="0"/>
@@ -13377,7 +11848,7 @@
                 <a:ea typeface="QuattrocentoSans" pitchFamily="34" charset="-122"/>
                 <a:cs typeface="QuattrocentoSans" pitchFamily="34" charset="-120"/>
               </a:rPr>
-              <a:t>4 / 10</a:t>
+              <a:t>4 / 12</a:t>
             </a:r>
             <a:endParaRPr lang="en-US" sz="1400" dirty="0">
               <a:latin typeface="Quattrocento Sans" panose="020B0502050000020003" pitchFamily="34" charset="0"/>
@@ -15256,7 +13727,7 @@
                 <a:ea typeface="QuattrocentoSans" pitchFamily="34" charset="-122"/>
                 <a:cs typeface="QuattrocentoSans" pitchFamily="34" charset="-120"/>
               </a:rPr>
-              <a:t>5 / 10</a:t>
+              <a:t>5 / 12</a:t>
             </a:r>
             <a:endParaRPr lang="en-US" sz="1400" dirty="0">
               <a:latin typeface="Quattrocento Sans" panose="020B0502050000020003" pitchFamily="34" charset="0"/>
@@ -17254,7 +15725,7 @@
                 <a:ea typeface="QuattrocentoSans" pitchFamily="34" charset="-122"/>
                 <a:cs typeface="QuattrocentoSans" pitchFamily="34" charset="-120"/>
               </a:rPr>
-              <a:t>6 / 10</a:t>
+              <a:t>6 / 12</a:t>
             </a:r>
             <a:endParaRPr lang="en-US" sz="1400" dirty="0">
               <a:latin typeface="Quattrocento Sans" panose="020B0502050000020003" pitchFamily="34" charset="0"/>
@@ -20956,7 +19427,7 @@
                 <a:ea typeface="QuattrocentoSans" pitchFamily="34" charset="-122"/>
                 <a:cs typeface="QuattrocentoSans" pitchFamily="34" charset="-120"/>
               </a:rPr>
-              <a:t>7 / 10</a:t>
+              <a:t>7 / 12</a:t>
             </a:r>
             <a:endParaRPr lang="en-US" sz="1400" dirty="0">
               <a:latin typeface="Quattrocento Sans" panose="020B0502050000020003" pitchFamily="34" charset="0"/>
@@ -23741,7 +22212,7 @@
                 <a:ea typeface="QuattrocentoSans" pitchFamily="34" charset="-122"/>
                 <a:cs typeface="QuattrocentoSans" pitchFamily="34" charset="-120"/>
               </a:rPr>
-              <a:t>8 / 10</a:t>
+              <a:t>8 / 12</a:t>
             </a:r>
             <a:endParaRPr lang="en-US" sz="1400" dirty="0">
               <a:latin typeface="Quattrocento Sans" panose="020B0502050000020003" pitchFamily="34" charset="0"/>
@@ -24818,7 +23289,7 @@
                 <a:ea typeface="QuattrocentoSans" pitchFamily="34" charset="-122"/>
                 <a:cs typeface="QuattrocentoSans" pitchFamily="34" charset="-120"/>
               </a:rPr>
-              <a:t>9 / 10</a:t>
+              <a:t>9 / 12</a:t>
             </a:r>
             <a:endParaRPr lang="en-US" sz="1400" dirty="0">
               <a:latin typeface="Quattrocento Sans" panose="020B0502050000020003" pitchFamily="34" charset="0"/>

</xml_diff>

<commit_message>
ponemos que sea requerido los inputs
</commit_message>
<xml_diff>
--- a/documentos/YourTree.pptx
+++ b/documentos/YourTree.pptx
@@ -11018,7 +11018,51 @@
                 <a:ea typeface="QuattrocentoSans" pitchFamily="34" charset="-122"/>
                 <a:cs typeface="QuattrocentoSans" pitchFamily="34" charset="-120"/>
               </a:rPr>
-              <a:t>PostgreSQL gestionado mediante Sequelize ORM para modelos relacionales y migraciones automáticas.</a:t>
+              <a:t>PostgreSQL para modelos relacionales y </a:t>
+            </a:r>
+            <a:r>
+              <a:rPr lang="en-US" sz="1600" dirty="0" err="1">
+                <a:solidFill>
+                  <a:srgbClr val="212529"/>
+                </a:solidFill>
+                <a:latin typeface="Quattrocento Sans" panose="020B0502050000020003" pitchFamily="34" charset="0"/>
+                <a:ea typeface="QuattrocentoSans" pitchFamily="34" charset="-122"/>
+                <a:cs typeface="QuattrocentoSans" pitchFamily="34" charset="-120"/>
+              </a:rPr>
+              <a:t>migraciones</a:t>
+            </a:r>
+            <a:r>
+              <a:rPr lang="en-US" sz="1600" dirty="0">
+                <a:solidFill>
+                  <a:srgbClr val="212529"/>
+                </a:solidFill>
+                <a:latin typeface="Quattrocento Sans" panose="020B0502050000020003" pitchFamily="34" charset="0"/>
+                <a:ea typeface="QuattrocentoSans" pitchFamily="34" charset="-122"/>
+                <a:cs typeface="QuattrocentoSans" pitchFamily="34" charset="-120"/>
+              </a:rPr>
+              <a:t> </a:t>
+            </a:r>
+            <a:r>
+              <a:rPr lang="en-US" sz="1600" dirty="0" err="1">
+                <a:solidFill>
+                  <a:srgbClr val="212529"/>
+                </a:solidFill>
+                <a:latin typeface="Quattrocento Sans" panose="020B0502050000020003" pitchFamily="34" charset="0"/>
+                <a:ea typeface="QuattrocentoSans" pitchFamily="34" charset="-122"/>
+                <a:cs typeface="QuattrocentoSans" pitchFamily="34" charset="-120"/>
+              </a:rPr>
+              <a:t>futuras</a:t>
+            </a:r>
+            <a:r>
+              <a:rPr lang="en-US" sz="1600" dirty="0">
+                <a:solidFill>
+                  <a:srgbClr val="212529"/>
+                </a:solidFill>
+                <a:latin typeface="Quattrocento Sans" panose="020B0502050000020003" pitchFamily="34" charset="0"/>
+                <a:ea typeface="QuattrocentoSans" pitchFamily="34" charset="-122"/>
+                <a:cs typeface="QuattrocentoSans" pitchFamily="34" charset="-120"/>
+              </a:rPr>
+              <a:t>.</a:t>
             </a:r>
             <a:endParaRPr lang="en-US" sz="1800" dirty="0">
               <a:latin typeface="Quattrocento Sans" panose="020B0502050000020003" pitchFamily="34" charset="0"/>
@@ -11720,7 +11764,7 @@
                 <a:ea typeface="Quattrocento Sans" pitchFamily="34" charset="-122"/>
                 <a:cs typeface="Quattrocento Sans" pitchFamily="34" charset="-120"/>
               </a:rPr>
-              <a:t>Sequelize Model → PostgreSQL</a:t>
+              <a:t>Model → PostgreSQL</a:t>
             </a:r>
             <a:endParaRPr lang="en-US" sz="1600" dirty="0">
               <a:latin typeface="Quattrocento Sans" panose="020B0502050000020003" pitchFamily="34" charset="0"/>
@@ -12194,7 +12238,7 @@
         <p:spPr>
           <a:xfrm>
             <a:off x="762000" y="1397000"/>
-            <a:ext cx="7112000" cy="5270500"/>
+            <a:ext cx="7366000" cy="5270500"/>
           </a:xfrm>
           <a:prstGeom prst="rect">
             <a:avLst/>
@@ -17183,7 +17227,7 @@
                 <a:ea typeface="Quattrocento Sans" pitchFamily="34" charset="-122"/>
                 <a:cs typeface="Quattrocento Sans" pitchFamily="34" charset="-120"/>
               </a:rPr>
-              <a:t>Consultas directas a la base de datos (PostgreSQL/Sequelize)</a:t>
+              <a:t>Consultas directas a la base de datos (PostgreSQL)</a:t>
             </a:r>
             <a:endParaRPr lang="en-US" sz="1600" dirty="0">
               <a:latin typeface="Quattrocento Sans" panose="020B0502050000020003" pitchFamily="34" charset="0"/>

</xml_diff>